<commit_message>
Alinha a apresentação do Momento 1 com o relatório
- Proposta de valor (slide 3 e notas) resumida a partir do relatório
- Guião do BMC (front stage, depois back stage) para 1-2 minutos,
  sem resultados do inquérito; números de página corrigidos
- Ano letivo 2026/2027 no relatório e no CLAUDE.md

Co-Authored-By: Claude Opus 5.5 <noreply@anthropic.com>
</commit_message>
<xml_diff>
--- a/Files/GrowNear — Momento 1.pptx
+++ b/Files/GrowNear — Momento 1.pptx
@@ -11,8 +11,8 @@
     <p:sldId id="256" r:id="rId2"/>
     <p:sldId id="257" r:id="rId3"/>
     <p:sldId id="258" r:id="rId4"/>
-    <p:sldId id="259" r:id="rId5"/>
-    <p:sldId id="260" r:id="rId6"/>
+    <p:sldId id="260" r:id="rId5"/>
+    <p:sldId id="259" r:id="rId6"/>
     <p:sldId id="261" r:id="rId7"/>
     <p:sldId id="262" r:id="rId8"/>
     <p:sldId id="263" r:id="rId9"/>
@@ -486,7 +486,7 @@
           <a:p>
             <a:r>
               <a:rPr lang="en-US" dirty="0"/>
-              <a:t>Proposta de valor para o comprador. Para quem quer produtos frescos e locais a preço justo e não tem acesso fácil a pequenos produtores, a GrowNear é uma app marketplace local que mostra o que há perto, com origem conhecida e pagamento seguro. Ao contrário do supermercado, do OLX ou dos grupos de Facebook, compra-se ao vizinho, com avaliações reais e reembolso garantido. Bónus para a comunidade: menos desperdício e dinheiro que fica na economia local.</a:t>
+              <a:t>Proposta de valor, com dois públicos. Para pequenos produtores com excedentes da horta, do pomar, do galinheiro ou das colmeias, que não conseguem escoar pequenas quantidades sem burocracia nem intermediários, e para compradores da zona que querem produtos frescos, de origem conhecida, perto de casa. A GrowNear é uma app marketplace local, com descoberta por mapa, que liga vizinhos: o comprador encontra o que há perto, reserva na app e recolhe em casa do produtor ou num ponto de recolha. Ao contrário de feiras e mercados, lojas biológicas e anúncios online genéricos, focamo-nos nos excedentes de quem não vive da produção, com alertas “avisem-me” para os produtos da época. O comprador paga menos do que numa loja biológica e sabe de onde vem o que come.</a:t>
             </a:r>
           </a:p>
         </p:txBody>
@@ -579,8 +579,38 @@
           <a:lstStyle/>
           <a:p>
             <a:r>
-              <a:rPr lang="en-US" dirty="0"/>
-              <a:t>Back stage: o que o cliente não vê. Parceiros para pagamentos, credibilidade institucional, acesso aos primeiros produtores e pontos de recolha. Atividades: manter a app, captar a oferta primeiro, zona a zona, e gerir a confiança. O recurso mais valioso é a rede de utilizadores. Custos: os maiores são a app e a aquisição de utilizadores; a operação é leve porque não temos stock nem entregas.</a:t>
+              <a:rPr lang="pt-PT" dirty="0"/>
+              <a:t>Passamos ao Business Model Canvas, começando pelo front stage: o que o cliente vê.</a:t>
+            </a:r>
+          </a:p>
+          <a:p>
+            <a:r>
+              <a:rPr lang="pt-PT" dirty="0"/>
+              <a:t>Segmentos: uma plataforma com dois lados. Os vendedores são prioritários, porque sem oferta não há compradores; do outro lado, quem quer frescos a bom preço, e também restaurantes e cafés.</a:t>
+            </a:r>
+          </a:p>
+          <a:p>
+            <a:r>
+              <a:rPr lang="pt-PT" dirty="0"/>
+              <a:t>Proposta de valor: o comprador tem produto fresco, perto e de origem conhecida; o vendedor transforma o excedente em rendimento, sem pagar nada.</a:t>
+            </a:r>
+          </a:p>
+          <a:p>
+            <a:r>
+              <a:rPr lang="pt-PT" dirty="0"/>
+              <a:t>Relação: autosserviço na app, com ajuda presencial no arranque e o programa “convida um vizinho”.</a:t>
+            </a:r>
+          </a:p>
+          <a:p>
+            <a:r>
+              <a:rPr lang="pt-PT" dirty="0"/>
+              <a:t>Canais: damo-nos a conhecer nas juntas, feiras e redes sociais; compra-se na app; recolhe-se em casa do produtor ou num ponto de recolha, como um café ou uma mercearia.</a:t>
+            </a:r>
+          </a:p>
+          <a:p>
+            <a:r>
+              <a:rPr lang="pt-PT" dirty="0"/>
+              <a:t>Receita: o comprador paga 0,50 € mais 5 % por compra, ou seja, 1 € numa encomenda de 10 €; para o vendedor, vender é grátis. Extra: destaque no mapa e, na fase 2, a GrowNear Pro.</a:t>
             </a:r>
           </a:p>
         </p:txBody>
@@ -673,8 +703,32 @@
           <a:lstStyle/>
           <a:p>
             <a:r>
-              <a:rPr lang="en-US" dirty="0"/>
-              <a:t>Front stage: o que o cliente vê. Plataforma multilateral com vendedores, que são prioritários porque sem oferta não há compradores, e compradores. Relação sobretudo em autosserviço, com ajuda presencial no arranque e o programa "convida um vizinho". Canais pela jornada do cliente: conhecer, comprar, receber e voltar. Receita: taxa de 0,50 € + 5 % ao comprador em cada compra paga na app (ex.: 0,75 € numa compra de 5 €); para o vendedor é grátis. Extra: destaque no mapa; fase 2: subscrição GrowNear Pro; parcerias com câmaras e juntas para campanhas anti-desperdício.</a:t>
+              <a:rPr lang="pt-PT" dirty="0"/>
+              <a:t>Agora o back stage: o que o cliente não vê, mas que sustenta tudo isto.</a:t>
+            </a:r>
+          </a:p>
+          <a:p>
+            <a:r>
+              <a:rPr lang="pt-PT" dirty="0"/>
+              <a:t>Parceiros: Stripe e MB Way para os pagamentos, juntas e câmaras para dar credibilidade, cooperativas para chegar aos primeiros produtores, e cafés e mercearias como pontos de recolha.</a:t>
+            </a:r>
+          </a:p>
+          <a:p>
+            <a:r>
+              <a:rPr lang="pt-PT" dirty="0"/>
+              <a:t>Atividades: manter a app, captar a oferta primeiro, zona a zona, e gerir a confiança, com moderação e reembolsos.</a:t>
+            </a:r>
+          </a:p>
+          <a:p>
+            <a:r>
+              <a:rPr lang="pt-PT" dirty="0"/>
+              <a:t>Recursos: o mais valioso é a rede de utilizadores; quanto mais vizinhos, mais útil a app.</a:t>
+            </a:r>
+          </a:p>
+          <a:p>
+            <a:r>
+              <a:rPr lang="pt-PT" dirty="0"/>
+              <a:t>Custos: os maiores são a app e a aquisição de utilizadores. A operação é leve, porque não temos stock nem fazemos entregas.</a:t>
             </a:r>
           </a:p>
         </p:txBody>
@@ -3184,7 +3238,7 @@
                 <a:ea typeface="Inter" pitchFamily="34" charset="-122"/>
                 <a:cs typeface="Inter" pitchFamily="34" charset="-120"/>
               </a:rPr>
-              <a:t>quem quer produtos frescos e locais, a preço justo</a:t>
+              <a:t>pequenos produtores com excedentes e compradores da zona</a:t>
             </a:r>
             <a:endParaRPr lang="en-US" sz="1500" dirty="0"/>
           </a:p>
@@ -3280,7 +3334,7 @@
                 <a:ea typeface="Inter" pitchFamily="34" charset="-122"/>
                 <a:cs typeface="Inter" pitchFamily="34" charset="-120"/>
               </a:rPr>
-              <a:t>não tem acesso fácil a pequenos produtores da sua zona</a:t>
+              <a:t>não conseguem escoar pequenas quantidades ou querem frescos perto de casa</a:t>
             </a:r>
             <a:endParaRPr lang="en-US" sz="1500" dirty="0"/>
           </a:p>
@@ -3472,7 +3526,7 @@
                 <a:ea typeface="Inter" pitchFamily="34" charset="-122"/>
                 <a:cs typeface="Inter" pitchFamily="34" charset="-120"/>
               </a:rPr>
-              <a:t>app marketplace local, com mapa, reservas e avaliações</a:t>
+              <a:t>app marketplace local, com descoberta por mapa</a:t>
             </a:r>
             <a:endParaRPr lang="en-US" sz="1500" dirty="0"/>
           </a:p>
@@ -3568,7 +3622,7 @@
                 <a:ea typeface="Inter" pitchFamily="34" charset="-122"/>
                 <a:cs typeface="Inter" pitchFamily="34" charset="-120"/>
               </a:rPr>
-              <a:t>mostra o que há perto de si, com origem conhecida e pagamento seguro</a:t>
+              <a:t>liga vizinhos: reserva na app e recolha no produtor ou num ponto de recolha</a:t>
             </a:r>
             <a:endParaRPr lang="en-US" sz="1500" dirty="0"/>
           </a:p>
@@ -3664,7 +3718,7 @@
                 <a:ea typeface="Inter" pitchFamily="34" charset="-122"/>
                 <a:cs typeface="Inter" pitchFamily="34" charset="-120"/>
               </a:rPr>
-              <a:t>supermercados, OLX ou grupos de Facebook</a:t>
+              <a:t>feiras e mercados, lojas biológicas e anúncios online genéricos</a:t>
             </a:r>
             <a:endParaRPr lang="en-US" sz="1500" dirty="0"/>
           </a:p>
@@ -3760,7 +3814,7 @@
                 <a:ea typeface="Inter" pitchFamily="34" charset="-122"/>
                 <a:cs typeface="Inter" pitchFamily="34" charset="-120"/>
               </a:rPr>
-              <a:t>produto colhido pelo vizinho, com avaliações reais e reembolso garantido</a:t>
+              <a:t>excedentes sem intermediários, alertas “avisem-me” e preço abaixo das lojas biológicas</a:t>
             </a:r>
             <a:endParaRPr lang="en-US" sz="1500" dirty="0"/>
           </a:p>
@@ -3863,6 +3917,1754 @@
 </file>
 
 <file path=ppt/slides/slide4.xml><?xml version="1.0" encoding="utf-8"?>
+<p:sld xmlns:a="http://schemas.openxmlformats.org/drawingml/2006/main" xmlns:r="http://schemas.openxmlformats.org/officeDocument/2006/relationships" xmlns:p="http://schemas.openxmlformats.org/presentationml/2006/main">
+  <p:cSld name="Slide 5">
+    <p:bg>
+      <p:bgPr>
+        <a:solidFill>
+          <a:srgbClr val="F7F3EC"/>
+        </a:solidFill>
+        <a:effectLst/>
+      </p:bgPr>
+    </p:bg>
+    <p:spTree>
+      <p:nvGrpSpPr>
+        <p:cNvPr id="1" name=""/>
+        <p:cNvGrpSpPr/>
+        <p:nvPr/>
+      </p:nvGrpSpPr>
+      <p:grpSpPr>
+        <a:xfrm>
+          <a:off x="0" y="0"/>
+          <a:ext cx="0" cy="0"/>
+          <a:chOff x="0" y="0"/>
+          <a:chExt cx="0" cy="0"/>
+        </a:xfrm>
+      </p:grpSpPr>
+      <p:sp>
+        <p:nvSpPr>
+          <p:cNvPr id="2" name="Text 0"/>
+          <p:cNvSpPr>
+            <a:spLocks noGrp="1"/>
+          </p:cNvSpPr>
+          <p:nvPr>
+            <p:ph type="title"/>
+          </p:nvPr>
+        </p:nvSpPr>
+        <p:spPr>
+          <a:xfrm>
+            <a:off x="812800" y="812800"/>
+            <a:ext cx="5669399" cy="472430"/>
+          </a:xfrm>
+          <a:prstGeom prst="rect">
+            <a:avLst/>
+          </a:prstGeom>
+          <a:noFill/>
+          <a:ln/>
+        </p:spPr>
+        <p:txBody>
+          <a:bodyPr wrap="square" lIns="0" tIns="0" rIns="0" bIns="0" rtlCol="0" anchor="t">
+            <a:normAutofit/>
+          </a:bodyPr>
+          <a:lstStyle/>
+          <a:p>
+            <a:pPr marL="0" indent="0" algn="l">
+              <a:lnSpc>
+                <a:spcPts val="3520"/>
+              </a:lnSpc>
+              <a:buNone/>
+            </a:pPr>
+            <a:r>
+              <a:rPr lang="en-US" sz="3200" b="1" i="0" dirty="0">
+                <a:solidFill>
+                  <a:srgbClr val="2D6A4F"/>
+                </a:solidFill>
+                <a:latin typeface="Inter" pitchFamily="34" charset="0"/>
+                <a:ea typeface="Inter" pitchFamily="34" charset="-122"/>
+                <a:cs typeface="Inter" pitchFamily="34" charset="-120"/>
+              </a:rPr>
+              <a:t>Business Model Canvas</a:t>
+            </a:r>
+            <a:endParaRPr lang="en-US" sz="3200" dirty="0"/>
+          </a:p>
+        </p:txBody>
+      </p:sp>
+      <p:sp>
+        <p:nvSpPr>
+          <p:cNvPr id="3" name="Text 1"/>
+          <p:cNvSpPr/>
+          <p:nvPr/>
+        </p:nvSpPr>
+        <p:spPr>
+          <a:xfrm>
+            <a:off x="9695607" y="909340"/>
+            <a:ext cx="1683593" cy="350490"/>
+          </a:xfrm>
+          <a:prstGeom prst="roundRect">
+            <a:avLst>
+              <a:gd name="adj" fmla="val 43482"/>
+            </a:avLst>
+          </a:prstGeom>
+          <a:solidFill>
+            <a:srgbClr val="C5703C"/>
+          </a:solidFill>
+          <a:ln/>
+        </p:spPr>
+        <p:txBody>
+          <a:bodyPr wrap="none" lIns="0" tIns="0" rIns="0" bIns="0" rtlCol="0" anchor="ctr">
+            <a:normAutofit/>
+          </a:bodyPr>
+          <a:lstStyle/>
+          <a:p>
+            <a:pPr marL="0" indent="0" algn="ctr">
+              <a:lnSpc>
+                <a:spcPts val="1960"/>
+              </a:lnSpc>
+              <a:buNone/>
+            </a:pPr>
+            <a:r>
+              <a:rPr lang="en-US" sz="1400" b="1" kern="0" spc="100" dirty="0">
+                <a:solidFill>
+                  <a:srgbClr val="FFFDF9"/>
+                </a:solidFill>
+                <a:latin typeface="Inter" pitchFamily="34" charset="0"/>
+                <a:ea typeface="Inter" pitchFamily="34" charset="-122"/>
+                <a:cs typeface="Inter" pitchFamily="34" charset="-120"/>
+              </a:rPr>
+              <a:t>FRONT STAGE</a:t>
+            </a:r>
+            <a:endParaRPr lang="en-US" sz="1400" dirty="0"/>
+          </a:p>
+        </p:txBody>
+      </p:sp>
+      <p:sp>
+        <p:nvSpPr>
+          <p:cNvPr id="4" name="Shape 2"/>
+          <p:cNvSpPr/>
+          <p:nvPr/>
+        </p:nvSpPr>
+        <p:spPr>
+          <a:xfrm>
+            <a:off x="812800" y="1437630"/>
+            <a:ext cx="2540000" cy="4404370"/>
+          </a:xfrm>
+          <a:prstGeom prst="roundRect">
+            <a:avLst>
+              <a:gd name="adj" fmla="val 3000"/>
+            </a:avLst>
+          </a:prstGeom>
+          <a:solidFill>
+            <a:srgbClr val="2D6A4F"/>
+          </a:solidFill>
+          <a:ln/>
+        </p:spPr>
+        <p:txBody>
+          <a:bodyPr/>
+          <a:lstStyle/>
+          <a:p>
+            <a:endParaRPr lang="pt-PT"/>
+          </a:p>
+        </p:txBody>
+      </p:sp>
+      <p:sp>
+        <p:nvSpPr>
+          <p:cNvPr id="5" name="Text 3"/>
+          <p:cNvSpPr/>
+          <p:nvPr/>
+        </p:nvSpPr>
+        <p:spPr>
+          <a:xfrm>
+            <a:off x="1016000" y="2367409"/>
+            <a:ext cx="2197608" cy="254000"/>
+          </a:xfrm>
+          <a:prstGeom prst="rect">
+            <a:avLst/>
+          </a:prstGeom>
+          <a:noFill/>
+          <a:ln/>
+        </p:spPr>
+        <p:txBody>
+          <a:bodyPr wrap="square" lIns="0" tIns="0" rIns="0" bIns="0" rtlCol="0" anchor="t">
+            <a:normAutofit/>
+          </a:bodyPr>
+          <a:lstStyle/>
+          <a:p>
+            <a:pPr marL="0" indent="0" algn="l">
+              <a:lnSpc>
+                <a:spcPts val="1800"/>
+              </a:lnSpc>
+              <a:buNone/>
+            </a:pPr>
+            <a:r>
+              <a:rPr lang="en-US" sz="1500" b="1" dirty="0">
+                <a:solidFill>
+                  <a:srgbClr val="F3D2BC"/>
+                </a:solidFill>
+                <a:latin typeface="Inter" pitchFamily="34" charset="0"/>
+                <a:ea typeface="Inter" pitchFamily="34" charset="-122"/>
+                <a:cs typeface="Inter" pitchFamily="34" charset="-120"/>
+              </a:rPr>
+              <a:t>Proposta de valor</a:t>
+            </a:r>
+            <a:endParaRPr lang="en-US" sz="1500" dirty="0"/>
+          </a:p>
+        </p:txBody>
+      </p:sp>
+      <p:sp>
+        <p:nvSpPr>
+          <p:cNvPr id="6" name="Text 4"/>
+          <p:cNvSpPr/>
+          <p:nvPr/>
+        </p:nvSpPr>
+        <p:spPr>
+          <a:xfrm>
+            <a:off x="1016000" y="2773809"/>
+            <a:ext cx="2197608" cy="817761"/>
+          </a:xfrm>
+          <a:prstGeom prst="rect">
+            <a:avLst/>
+          </a:prstGeom>
+          <a:noFill/>
+          <a:ln/>
+        </p:spPr>
+        <p:txBody>
+          <a:bodyPr wrap="square" lIns="0" tIns="0" rIns="0" bIns="0" rtlCol="0" anchor="t">
+            <a:normAutofit/>
+          </a:bodyPr>
+          <a:lstStyle/>
+          <a:p>
+            <a:pPr marL="0" indent="0" algn="l">
+              <a:lnSpc>
+                <a:spcPts val="1560"/>
+              </a:lnSpc>
+              <a:buNone/>
+            </a:pPr>
+            <a:r>
+              <a:rPr lang="en-US" sz="1200" b="1" dirty="0">
+                <a:solidFill>
+                  <a:srgbClr val="FFFDF9"/>
+                </a:solidFill>
+                <a:latin typeface="Inter" pitchFamily="34" charset="0"/>
+                <a:ea typeface="Inter" pitchFamily="34" charset="-122"/>
+                <a:cs typeface="Inter" pitchFamily="34" charset="-120"/>
+              </a:rPr>
+              <a:t>Compradores:</a:t>
+            </a:r>
+            <a:r>
+              <a:rPr lang="en-US" sz="1200" dirty="0">
+                <a:solidFill>
+                  <a:srgbClr val="FFFDF9"/>
+                </a:solidFill>
+                <a:latin typeface="Inter" pitchFamily="34" charset="0"/>
+                <a:ea typeface="Inter" pitchFamily="34" charset="-122"/>
+                <a:cs typeface="Inter" pitchFamily="34" charset="-120"/>
+              </a:rPr>
+              <a:t> frescos e locais, perto de casa, com origem conhecida e pagamento seguro</a:t>
+            </a:r>
+            <a:endParaRPr lang="en-US" sz="1200" dirty="0"/>
+          </a:p>
+        </p:txBody>
+      </p:sp>
+      <p:sp>
+        <p:nvSpPr>
+          <p:cNvPr id="7" name="Text 5"/>
+          <p:cNvSpPr/>
+          <p:nvPr/>
+        </p:nvSpPr>
+        <p:spPr>
+          <a:xfrm>
+            <a:off x="1016000" y="3743970"/>
+            <a:ext cx="2197608" cy="619671"/>
+          </a:xfrm>
+          <a:prstGeom prst="rect">
+            <a:avLst/>
+          </a:prstGeom>
+          <a:noFill/>
+          <a:ln/>
+        </p:spPr>
+        <p:txBody>
+          <a:bodyPr wrap="square" lIns="0" tIns="0" rIns="0" bIns="0" rtlCol="0" anchor="t">
+            <a:normAutofit/>
+          </a:bodyPr>
+          <a:lstStyle/>
+          <a:p>
+            <a:pPr marL="0" indent="0" algn="l">
+              <a:lnSpc>
+                <a:spcPts val="1560"/>
+              </a:lnSpc>
+              <a:buNone/>
+            </a:pPr>
+            <a:r>
+              <a:rPr lang="en-US" sz="1200" b="1" dirty="0">
+                <a:solidFill>
+                  <a:srgbClr val="FFFDF9"/>
+                </a:solidFill>
+                <a:latin typeface="Inter" pitchFamily="34" charset="0"/>
+                <a:ea typeface="Inter" pitchFamily="34" charset="-122"/>
+                <a:cs typeface="Inter" pitchFamily="34" charset="-120"/>
+              </a:rPr>
+              <a:t>Vendedores:</a:t>
+            </a:r>
+            <a:r>
+              <a:rPr lang="en-US" sz="1200" dirty="0">
+                <a:solidFill>
+                  <a:srgbClr val="FFFDF9"/>
+                </a:solidFill>
+                <a:latin typeface="Inter" pitchFamily="34" charset="0"/>
+                <a:ea typeface="Inter" pitchFamily="34" charset="-122"/>
+                <a:cs typeface="Inter" pitchFamily="34" charset="-120"/>
+              </a:rPr>
+              <a:t> o excedente vira rendimento; anunciar é grátis</a:t>
+            </a:r>
+            <a:endParaRPr lang="en-US" sz="1200" dirty="0"/>
+          </a:p>
+        </p:txBody>
+      </p:sp>
+      <p:sp>
+        <p:nvSpPr>
+          <p:cNvPr id="8" name="Text 6"/>
+          <p:cNvSpPr/>
+          <p:nvPr/>
+        </p:nvSpPr>
+        <p:spPr>
+          <a:xfrm>
+            <a:off x="1016000" y="4516041"/>
+            <a:ext cx="2197608" cy="421580"/>
+          </a:xfrm>
+          <a:prstGeom prst="rect">
+            <a:avLst/>
+          </a:prstGeom>
+          <a:noFill/>
+          <a:ln/>
+        </p:spPr>
+        <p:txBody>
+          <a:bodyPr wrap="square" lIns="0" tIns="0" rIns="0" bIns="0" rtlCol="0" anchor="t">
+            <a:normAutofit/>
+          </a:bodyPr>
+          <a:lstStyle/>
+          <a:p>
+            <a:pPr marL="0" indent="0" algn="l">
+              <a:lnSpc>
+                <a:spcPts val="1560"/>
+              </a:lnSpc>
+              <a:buNone/>
+            </a:pPr>
+            <a:r>
+              <a:rPr lang="en-US" sz="1200" b="1" dirty="0">
+                <a:solidFill>
+                  <a:srgbClr val="FFFDF9"/>
+                </a:solidFill>
+                <a:latin typeface="Inter" pitchFamily="34" charset="0"/>
+                <a:ea typeface="Inter" pitchFamily="34" charset="-122"/>
+                <a:cs typeface="Inter" pitchFamily="34" charset="-120"/>
+              </a:rPr>
+              <a:t>Comunidade:</a:t>
+            </a:r>
+            <a:r>
+              <a:rPr lang="en-US" sz="1200" dirty="0">
+                <a:solidFill>
+                  <a:srgbClr val="FFFDF9"/>
+                </a:solidFill>
+                <a:latin typeface="Inter" pitchFamily="34" charset="0"/>
+                <a:ea typeface="Inter" pitchFamily="34" charset="-122"/>
+                <a:cs typeface="Inter" pitchFamily="34" charset="-120"/>
+              </a:rPr>
+              <a:t> menos desperdício e economia local</a:t>
+            </a:r>
+            <a:endParaRPr lang="en-US" sz="1200" dirty="0"/>
+          </a:p>
+        </p:txBody>
+      </p:sp>
+      <p:sp>
+        <p:nvSpPr>
+          <p:cNvPr id="9" name="Shape 7"/>
+          <p:cNvSpPr/>
+          <p:nvPr/>
+        </p:nvSpPr>
+        <p:spPr>
+          <a:xfrm>
+            <a:off x="3505200" y="1437630"/>
+            <a:ext cx="3860800" cy="2125960"/>
+          </a:xfrm>
+          <a:prstGeom prst="roundRect">
+            <a:avLst>
+              <a:gd name="adj" fmla="val 3584"/>
+            </a:avLst>
+          </a:prstGeom>
+          <a:solidFill>
+            <a:srgbClr val="FFFDF9"/>
+          </a:solidFill>
+          <a:ln/>
+        </p:spPr>
+        <p:txBody>
+          <a:bodyPr/>
+          <a:lstStyle/>
+          <a:p>
+            <a:endParaRPr lang="pt-PT"/>
+          </a:p>
+        </p:txBody>
+      </p:sp>
+      <p:sp>
+        <p:nvSpPr>
+          <p:cNvPr id="10" name="Shape 8"/>
+          <p:cNvSpPr/>
+          <p:nvPr/>
+        </p:nvSpPr>
+        <p:spPr>
+          <a:xfrm>
+            <a:off x="3505200" y="1437630"/>
+            <a:ext cx="3860800" cy="2125960"/>
+          </a:xfrm>
+          <a:custGeom>
+            <a:avLst/>
+            <a:gdLst/>
+            <a:ahLst/>
+            <a:cxnLst/>
+            <a:rect l="l" t="t" r="r" b="b"/>
+            <a:pathLst>
+              <a:path w="3860800" h="2125960">
+                <a:moveTo>
+                  <a:pt x="0" y="76200"/>
+                </a:moveTo>
+                <a:lnTo>
+                  <a:pt x="0" y="76200"/>
+                </a:lnTo>
+                <a:arcTo wR="76200" hR="76200" stAng="10800000" swAng="5400000"/>
+                <a:lnTo>
+                  <a:pt x="3784600" y="0"/>
+                </a:lnTo>
+                <a:arcTo wR="76200" hR="76200" stAng="16200000" swAng="5400000"/>
+                <a:lnTo>
+                  <a:pt x="3860800" y="76200"/>
+                </a:lnTo>
+                <a:arcTo wR="76200" hR="25400" stAng="0" swAng="-5400000"/>
+                <a:lnTo>
+                  <a:pt x="76200" y="50800"/>
+                </a:lnTo>
+                <a:arcTo wR="76200" hR="25400" stAng="16200000" swAng="-5400000"/>
+                <a:close/>
+              </a:path>
+            </a:pathLst>
+          </a:custGeom>
+          <a:solidFill>
+            <a:srgbClr val="2D6A4F"/>
+          </a:solidFill>
+          <a:ln/>
+        </p:spPr>
+        <p:txBody>
+          <a:bodyPr/>
+          <a:lstStyle/>
+          <a:p>
+            <a:endParaRPr lang="pt-PT"/>
+          </a:p>
+        </p:txBody>
+      </p:sp>
+      <p:sp>
+        <p:nvSpPr>
+          <p:cNvPr id="11" name="Text 9"/>
+          <p:cNvSpPr/>
+          <p:nvPr/>
+        </p:nvSpPr>
+        <p:spPr>
+          <a:xfrm>
+            <a:off x="3695700" y="1640830"/>
+            <a:ext cx="3584194" cy="254000"/>
+          </a:xfrm>
+          <a:prstGeom prst="rect">
+            <a:avLst/>
+          </a:prstGeom>
+          <a:noFill/>
+          <a:ln/>
+        </p:spPr>
+        <p:txBody>
+          <a:bodyPr wrap="square" lIns="0" tIns="0" rIns="0" bIns="0" rtlCol="0" anchor="t">
+            <a:normAutofit/>
+          </a:bodyPr>
+          <a:lstStyle/>
+          <a:p>
+            <a:pPr marL="0" indent="0" algn="l">
+              <a:lnSpc>
+                <a:spcPts val="1800"/>
+              </a:lnSpc>
+              <a:buNone/>
+            </a:pPr>
+            <a:r>
+              <a:rPr lang="en-US" sz="1500" b="1" dirty="0">
+                <a:solidFill>
+                  <a:srgbClr val="2D6A4F"/>
+                </a:solidFill>
+                <a:latin typeface="Inter" pitchFamily="34" charset="0"/>
+                <a:ea typeface="Inter" pitchFamily="34" charset="-122"/>
+                <a:cs typeface="Inter" pitchFamily="34" charset="-120"/>
+              </a:rPr>
+              <a:t>Segmentos de clientes</a:t>
+            </a:r>
+            <a:endParaRPr lang="en-US" sz="1500" dirty="0"/>
+          </a:p>
+        </p:txBody>
+      </p:sp>
+      <p:sp>
+        <p:nvSpPr>
+          <p:cNvPr id="12" name="Text 10"/>
+          <p:cNvSpPr/>
+          <p:nvPr/>
+        </p:nvSpPr>
+        <p:spPr>
+          <a:xfrm>
+            <a:off x="3695700" y="1932930"/>
+            <a:ext cx="3584194" cy="406400"/>
+          </a:xfrm>
+          <a:prstGeom prst="rect">
+            <a:avLst/>
+          </a:prstGeom>
+          <a:noFill/>
+          <a:ln/>
+        </p:spPr>
+        <p:txBody>
+          <a:bodyPr wrap="square" lIns="0" tIns="0" rIns="0" bIns="0" rtlCol="0" anchor="t">
+            <a:normAutofit/>
+          </a:bodyPr>
+          <a:lstStyle/>
+          <a:p>
+            <a:pPr marL="0" indent="0" algn="l">
+              <a:lnSpc>
+                <a:spcPts val="1500"/>
+              </a:lnSpc>
+              <a:buNone/>
+            </a:pPr>
+            <a:r>
+              <a:rPr lang="en-US" sz="1200" b="1" dirty="0">
+                <a:solidFill>
+                  <a:srgbClr val="1E2B24"/>
+                </a:solidFill>
+                <a:latin typeface="Inter" pitchFamily="34" charset="0"/>
+                <a:ea typeface="Inter" pitchFamily="34" charset="-122"/>
+                <a:cs typeface="Inter" pitchFamily="34" charset="-120"/>
+              </a:rPr>
+              <a:t>Multilateral:</a:t>
+            </a:r>
+            <a:r>
+              <a:rPr lang="en-US" sz="1200" dirty="0">
+                <a:solidFill>
+                  <a:srgbClr val="1E2B24"/>
+                </a:solidFill>
+                <a:latin typeface="Inter" pitchFamily="34" charset="0"/>
+                <a:ea typeface="Inter" pitchFamily="34" charset="-122"/>
+                <a:cs typeface="Inter" pitchFamily="34" charset="-120"/>
+              </a:rPr>
+              <a:t> dois públicos que precisam um do outro</a:t>
+            </a:r>
+            <a:endParaRPr lang="en-US" sz="1200" dirty="0"/>
+          </a:p>
+        </p:txBody>
+      </p:sp>
+      <p:sp>
+        <p:nvSpPr>
+          <p:cNvPr id="13" name="Text 11"/>
+          <p:cNvSpPr/>
+          <p:nvPr/>
+        </p:nvSpPr>
+        <p:spPr>
+          <a:xfrm>
+            <a:off x="3695700" y="2377430"/>
+            <a:ext cx="3584194" cy="406400"/>
+          </a:xfrm>
+          <a:prstGeom prst="rect">
+            <a:avLst/>
+          </a:prstGeom>
+          <a:noFill/>
+          <a:ln/>
+        </p:spPr>
+        <p:txBody>
+          <a:bodyPr wrap="square" lIns="0" tIns="0" rIns="0" bIns="0" rtlCol="0" anchor="t">
+            <a:normAutofit/>
+          </a:bodyPr>
+          <a:lstStyle/>
+          <a:p>
+            <a:pPr marL="0" indent="0" algn="l">
+              <a:lnSpc>
+                <a:spcPts val="1500"/>
+              </a:lnSpc>
+              <a:buNone/>
+            </a:pPr>
+            <a:r>
+              <a:rPr lang="en-US" sz="1200" b="1" dirty="0">
+                <a:solidFill>
+                  <a:srgbClr val="1E2B24"/>
+                </a:solidFill>
+                <a:latin typeface="Inter" pitchFamily="34" charset="0"/>
+                <a:ea typeface="Inter" pitchFamily="34" charset="-122"/>
+                <a:cs typeface="Inter" pitchFamily="34" charset="-120"/>
+              </a:rPr>
+              <a:t>Vendedores (prioritários):</a:t>
+            </a:r>
+            <a:r>
+              <a:rPr lang="en-US" sz="1200" dirty="0">
+                <a:solidFill>
+                  <a:srgbClr val="1E2B24"/>
+                </a:solidFill>
+                <a:latin typeface="Inter" pitchFamily="34" charset="0"/>
+                <a:ea typeface="Inter" pitchFamily="34" charset="-122"/>
+                <a:cs typeface="Inter" pitchFamily="34" charset="-120"/>
+              </a:rPr>
+              <a:t> hortas, pomares, animais e colmeias</a:t>
+            </a:r>
+            <a:endParaRPr lang="en-US" sz="1200" dirty="0"/>
+          </a:p>
+        </p:txBody>
+      </p:sp>
+      <p:sp>
+        <p:nvSpPr>
+          <p:cNvPr id="14" name="Text 12"/>
+          <p:cNvSpPr/>
+          <p:nvPr/>
+        </p:nvSpPr>
+        <p:spPr>
+          <a:xfrm>
+            <a:off x="3695700" y="2821930"/>
+            <a:ext cx="3584194" cy="406400"/>
+          </a:xfrm>
+          <a:prstGeom prst="rect">
+            <a:avLst/>
+          </a:prstGeom>
+          <a:noFill/>
+          <a:ln/>
+        </p:spPr>
+        <p:txBody>
+          <a:bodyPr wrap="square" lIns="0" tIns="0" rIns="0" bIns="0" rtlCol="0" anchor="t">
+            <a:normAutofit/>
+          </a:bodyPr>
+          <a:lstStyle/>
+          <a:p>
+            <a:pPr marL="0" indent="0" algn="l">
+              <a:lnSpc>
+                <a:spcPts val="1500"/>
+              </a:lnSpc>
+              <a:buNone/>
+            </a:pPr>
+            <a:r>
+              <a:rPr lang="en-US" sz="1200" b="1" dirty="0">
+                <a:solidFill>
+                  <a:srgbClr val="1E2B24"/>
+                </a:solidFill>
+                <a:latin typeface="Inter" pitchFamily="34" charset="0"/>
+                <a:ea typeface="Inter" pitchFamily="34" charset="-122"/>
+                <a:cs typeface="Inter" pitchFamily="34" charset="-120"/>
+              </a:rPr>
+              <a:t>Compradores:</a:t>
+            </a:r>
+            <a:r>
+              <a:rPr lang="en-US" sz="1200" dirty="0">
+                <a:solidFill>
+                  <a:srgbClr val="1E2B24"/>
+                </a:solidFill>
+                <a:latin typeface="Inter" pitchFamily="34" charset="0"/>
+                <a:ea typeface="Inter" pitchFamily="34" charset="-122"/>
+                <a:cs typeface="Inter" pitchFamily="34" charset="-120"/>
+              </a:rPr>
+              <a:t> quem quer frescos a bom preço; restaurantes e cafés</a:t>
+            </a:r>
+            <a:endParaRPr lang="en-US" sz="1200" dirty="0"/>
+          </a:p>
+        </p:txBody>
+      </p:sp>
+      <p:sp>
+        <p:nvSpPr>
+          <p:cNvPr id="15" name="Shape 13"/>
+          <p:cNvSpPr/>
+          <p:nvPr/>
+        </p:nvSpPr>
+        <p:spPr>
+          <a:xfrm>
+            <a:off x="7518400" y="1437630"/>
+            <a:ext cx="3860800" cy="2125960"/>
+          </a:xfrm>
+          <a:prstGeom prst="roundRect">
+            <a:avLst>
+              <a:gd name="adj" fmla="val 3584"/>
+            </a:avLst>
+          </a:prstGeom>
+          <a:solidFill>
+            <a:srgbClr val="FFFDF9"/>
+          </a:solidFill>
+          <a:ln/>
+        </p:spPr>
+        <p:txBody>
+          <a:bodyPr/>
+          <a:lstStyle/>
+          <a:p>
+            <a:endParaRPr lang="pt-PT"/>
+          </a:p>
+        </p:txBody>
+      </p:sp>
+      <p:sp>
+        <p:nvSpPr>
+          <p:cNvPr id="16" name="Shape 14"/>
+          <p:cNvSpPr/>
+          <p:nvPr/>
+        </p:nvSpPr>
+        <p:spPr>
+          <a:xfrm>
+            <a:off x="7518400" y="1437630"/>
+            <a:ext cx="3860800" cy="2125960"/>
+          </a:xfrm>
+          <a:custGeom>
+            <a:avLst/>
+            <a:gdLst/>
+            <a:ahLst/>
+            <a:cxnLst/>
+            <a:rect l="l" t="t" r="r" b="b"/>
+            <a:pathLst>
+              <a:path w="3860800" h="2125960">
+                <a:moveTo>
+                  <a:pt x="0" y="76200"/>
+                </a:moveTo>
+                <a:lnTo>
+                  <a:pt x="0" y="76200"/>
+                </a:lnTo>
+                <a:arcTo wR="76200" hR="76200" stAng="10800000" swAng="5400000"/>
+                <a:lnTo>
+                  <a:pt x="3784600" y="0"/>
+                </a:lnTo>
+                <a:arcTo wR="76200" hR="76200" stAng="16200000" swAng="5400000"/>
+                <a:lnTo>
+                  <a:pt x="3860800" y="76200"/>
+                </a:lnTo>
+                <a:arcTo wR="76200" hR="25400" stAng="0" swAng="-5400000"/>
+                <a:lnTo>
+                  <a:pt x="76200" y="50800"/>
+                </a:lnTo>
+                <a:arcTo wR="76200" hR="25400" stAng="16200000" swAng="-5400000"/>
+                <a:close/>
+              </a:path>
+            </a:pathLst>
+          </a:custGeom>
+          <a:solidFill>
+            <a:srgbClr val="2D6A4F"/>
+          </a:solidFill>
+          <a:ln/>
+        </p:spPr>
+        <p:txBody>
+          <a:bodyPr/>
+          <a:lstStyle/>
+          <a:p>
+            <a:endParaRPr lang="pt-PT"/>
+          </a:p>
+        </p:txBody>
+      </p:sp>
+      <p:sp>
+        <p:nvSpPr>
+          <p:cNvPr id="17" name="Text 15"/>
+          <p:cNvSpPr/>
+          <p:nvPr/>
+        </p:nvSpPr>
+        <p:spPr>
+          <a:xfrm>
+            <a:off x="7708900" y="1640830"/>
+            <a:ext cx="3584194" cy="254000"/>
+          </a:xfrm>
+          <a:prstGeom prst="rect">
+            <a:avLst/>
+          </a:prstGeom>
+          <a:noFill/>
+          <a:ln/>
+        </p:spPr>
+        <p:txBody>
+          <a:bodyPr wrap="square" lIns="0" tIns="0" rIns="0" bIns="0" rtlCol="0" anchor="t">
+            <a:normAutofit/>
+          </a:bodyPr>
+          <a:lstStyle/>
+          <a:p>
+            <a:pPr marL="0" indent="0" algn="l">
+              <a:lnSpc>
+                <a:spcPts val="1800"/>
+              </a:lnSpc>
+              <a:buNone/>
+            </a:pPr>
+            <a:r>
+              <a:rPr lang="en-US" sz="1500" b="1" dirty="0">
+                <a:solidFill>
+                  <a:srgbClr val="2D6A4F"/>
+                </a:solidFill>
+                <a:latin typeface="Inter" pitchFamily="34" charset="0"/>
+                <a:ea typeface="Inter" pitchFamily="34" charset="-122"/>
+                <a:cs typeface="Inter" pitchFamily="34" charset="-120"/>
+              </a:rPr>
+              <a:t>Relações com clientes</a:t>
+            </a:r>
+            <a:endParaRPr lang="en-US" sz="1500" dirty="0"/>
+          </a:p>
+        </p:txBody>
+      </p:sp>
+      <p:sp>
+        <p:nvSpPr>
+          <p:cNvPr id="18" name="Text 16"/>
+          <p:cNvSpPr/>
+          <p:nvPr/>
+        </p:nvSpPr>
+        <p:spPr>
+          <a:xfrm>
+            <a:off x="7708900" y="1932930"/>
+            <a:ext cx="3584194" cy="215900"/>
+          </a:xfrm>
+          <a:prstGeom prst="rect">
+            <a:avLst/>
+          </a:prstGeom>
+          <a:noFill/>
+          <a:ln/>
+        </p:spPr>
+        <p:txBody>
+          <a:bodyPr wrap="square" lIns="0" tIns="0" rIns="0" bIns="0" rtlCol="0" anchor="t">
+            <a:normAutofit/>
+          </a:bodyPr>
+          <a:lstStyle/>
+          <a:p>
+            <a:pPr marL="0" indent="0" algn="l">
+              <a:lnSpc>
+                <a:spcPts val="1500"/>
+              </a:lnSpc>
+              <a:buNone/>
+            </a:pPr>
+            <a:r>
+              <a:rPr lang="en-US" sz="1200" b="1" dirty="0">
+                <a:solidFill>
+                  <a:srgbClr val="1E2B24"/>
+                </a:solidFill>
+                <a:latin typeface="Inter" pitchFamily="34" charset="0"/>
+                <a:ea typeface="Inter" pitchFamily="34" charset="-122"/>
+                <a:cs typeface="Inter" pitchFamily="34" charset="-120"/>
+              </a:rPr>
+              <a:t>Autosserviço</a:t>
+            </a:r>
+            <a:r>
+              <a:rPr lang="en-US" sz="1200" dirty="0">
+                <a:solidFill>
+                  <a:srgbClr val="1E2B24"/>
+                </a:solidFill>
+                <a:latin typeface="Inter" pitchFamily="34" charset="0"/>
+                <a:ea typeface="Inter" pitchFamily="34" charset="-122"/>
+                <a:cs typeface="Inter" pitchFamily="34" charset="-120"/>
+              </a:rPr>
+              <a:t> na app e avaliações mútuas</a:t>
+            </a:r>
+            <a:endParaRPr lang="en-US" sz="1200" dirty="0"/>
+          </a:p>
+        </p:txBody>
+      </p:sp>
+      <p:sp>
+        <p:nvSpPr>
+          <p:cNvPr id="19" name="Text 17"/>
+          <p:cNvSpPr/>
+          <p:nvPr/>
+        </p:nvSpPr>
+        <p:spPr>
+          <a:xfrm>
+            <a:off x="7708900" y="2186930"/>
+            <a:ext cx="3584194" cy="406400"/>
+          </a:xfrm>
+          <a:prstGeom prst="rect">
+            <a:avLst/>
+          </a:prstGeom>
+          <a:noFill/>
+          <a:ln/>
+        </p:spPr>
+        <p:txBody>
+          <a:bodyPr wrap="square" lIns="0" tIns="0" rIns="0" bIns="0" rtlCol="0" anchor="t">
+            <a:normAutofit/>
+          </a:bodyPr>
+          <a:lstStyle/>
+          <a:p>
+            <a:pPr marL="0" indent="0" algn="l">
+              <a:lnSpc>
+                <a:spcPts val="1500"/>
+              </a:lnSpc>
+              <a:buNone/>
+            </a:pPr>
+            <a:r>
+              <a:rPr lang="en-US" sz="1200" b="1" dirty="0">
+                <a:solidFill>
+                  <a:srgbClr val="1E2B24"/>
+                </a:solidFill>
+                <a:latin typeface="Inter" pitchFamily="34" charset="0"/>
+                <a:ea typeface="Inter" pitchFamily="34" charset="-122"/>
+                <a:cs typeface="Inter" pitchFamily="34" charset="-120"/>
+              </a:rPr>
+              <a:t>Arranque:</a:t>
+            </a:r>
+            <a:r>
+              <a:rPr lang="en-US" sz="1200" dirty="0">
+                <a:solidFill>
+                  <a:srgbClr val="1E2B24"/>
+                </a:solidFill>
+                <a:latin typeface="Inter" pitchFamily="34" charset="0"/>
+                <a:ea typeface="Inter" pitchFamily="34" charset="-122"/>
+                <a:cs typeface="Inter" pitchFamily="34" charset="-120"/>
+              </a:rPr>
+              <a:t> ajuda presencial aos primeiros produtores</a:t>
+            </a:r>
+            <a:endParaRPr lang="en-US" sz="1200" dirty="0"/>
+          </a:p>
+        </p:txBody>
+      </p:sp>
+      <p:sp>
+        <p:nvSpPr>
+          <p:cNvPr id="20" name="Text 18"/>
+          <p:cNvSpPr/>
+          <p:nvPr/>
+        </p:nvSpPr>
+        <p:spPr>
+          <a:xfrm>
+            <a:off x="7708900" y="2631430"/>
+            <a:ext cx="3670300" cy="215900"/>
+          </a:xfrm>
+          <a:prstGeom prst="rect">
+            <a:avLst/>
+          </a:prstGeom>
+          <a:noFill/>
+          <a:ln/>
+        </p:spPr>
+        <p:txBody>
+          <a:bodyPr wrap="square" lIns="0" tIns="0" rIns="0" bIns="0" rtlCol="0" anchor="t">
+            <a:normAutofit/>
+          </a:bodyPr>
+          <a:lstStyle/>
+          <a:p>
+            <a:pPr marL="0" indent="0" algn="l">
+              <a:lnSpc>
+                <a:spcPts val="1500"/>
+              </a:lnSpc>
+              <a:buNone/>
+            </a:pPr>
+            <a:r>
+              <a:rPr lang="en-US" sz="1200" b="1" dirty="0">
+                <a:solidFill>
+                  <a:srgbClr val="1E2B24"/>
+                </a:solidFill>
+                <a:latin typeface="Inter" pitchFamily="34" charset="0"/>
+                <a:ea typeface="Inter" pitchFamily="34" charset="-122"/>
+                <a:cs typeface="Inter" pitchFamily="34" charset="-120"/>
+              </a:rPr>
+              <a:t>“Convida um vizinho”</a:t>
+            </a:r>
+            <a:r>
+              <a:rPr lang="en-US" sz="1200" dirty="0">
+                <a:solidFill>
+                  <a:srgbClr val="1E2B24"/>
+                </a:solidFill>
+                <a:latin typeface="Inter" pitchFamily="34" charset="0"/>
+                <a:ea typeface="Inter" pitchFamily="34" charset="-122"/>
+                <a:cs typeface="Inter" pitchFamily="34" charset="-120"/>
+              </a:rPr>
+              <a:t> com crédito para ambos</a:t>
+            </a:r>
+            <a:endParaRPr lang="en-US" sz="1200" dirty="0"/>
+          </a:p>
+        </p:txBody>
+      </p:sp>
+      <p:sp>
+        <p:nvSpPr>
+          <p:cNvPr id="21" name="Text 19"/>
+          <p:cNvSpPr/>
+          <p:nvPr/>
+        </p:nvSpPr>
+        <p:spPr>
+          <a:xfrm>
+            <a:off x="7708900" y="2885430"/>
+            <a:ext cx="3584194" cy="215900"/>
+          </a:xfrm>
+          <a:prstGeom prst="rect">
+            <a:avLst/>
+          </a:prstGeom>
+          <a:noFill/>
+          <a:ln/>
+        </p:spPr>
+        <p:txBody>
+          <a:bodyPr wrap="square" lIns="0" tIns="0" rIns="0" bIns="0" rtlCol="0" anchor="t">
+            <a:normAutofit/>
+          </a:bodyPr>
+          <a:lstStyle/>
+          <a:p>
+            <a:pPr marL="0" indent="0" algn="l">
+              <a:lnSpc>
+                <a:spcPts val="1500"/>
+              </a:lnSpc>
+              <a:buNone/>
+            </a:pPr>
+            <a:r>
+              <a:rPr lang="en-US" sz="1200" b="1" dirty="0">
+                <a:solidFill>
+                  <a:srgbClr val="1E2B24"/>
+                </a:solidFill>
+                <a:latin typeface="Inter" pitchFamily="34" charset="0"/>
+                <a:ea typeface="Inter" pitchFamily="34" charset="-122"/>
+                <a:cs typeface="Inter" pitchFamily="34" charset="-120"/>
+              </a:rPr>
+              <a:t>Fidelização:</a:t>
+            </a:r>
+            <a:r>
+              <a:rPr lang="en-US" sz="1200" dirty="0">
+                <a:solidFill>
+                  <a:srgbClr val="1E2B24"/>
+                </a:solidFill>
+                <a:latin typeface="Inter" pitchFamily="34" charset="0"/>
+                <a:ea typeface="Inter" pitchFamily="34" charset="-122"/>
+                <a:cs typeface="Inter" pitchFamily="34" charset="-120"/>
+              </a:rPr>
+              <a:t> alertas de disponibilidade</a:t>
+            </a:r>
+            <a:endParaRPr lang="en-US" sz="1200" dirty="0"/>
+          </a:p>
+        </p:txBody>
+      </p:sp>
+      <p:sp>
+        <p:nvSpPr>
+          <p:cNvPr id="22" name="Shape 20"/>
+          <p:cNvSpPr/>
+          <p:nvPr/>
+        </p:nvSpPr>
+        <p:spPr>
+          <a:xfrm>
+            <a:off x="3505200" y="3715990"/>
+            <a:ext cx="3860800" cy="2126010"/>
+          </a:xfrm>
+          <a:prstGeom prst="roundRect">
+            <a:avLst>
+              <a:gd name="adj" fmla="val 3584"/>
+            </a:avLst>
+          </a:prstGeom>
+          <a:solidFill>
+            <a:srgbClr val="FFFDF9"/>
+          </a:solidFill>
+          <a:ln/>
+        </p:spPr>
+        <p:txBody>
+          <a:bodyPr/>
+          <a:lstStyle/>
+          <a:p>
+            <a:endParaRPr lang="pt-PT"/>
+          </a:p>
+        </p:txBody>
+      </p:sp>
+      <p:sp>
+        <p:nvSpPr>
+          <p:cNvPr id="23" name="Shape 21"/>
+          <p:cNvSpPr/>
+          <p:nvPr/>
+        </p:nvSpPr>
+        <p:spPr>
+          <a:xfrm>
+            <a:off x="3505200" y="3715990"/>
+            <a:ext cx="3860800" cy="2126010"/>
+          </a:xfrm>
+          <a:custGeom>
+            <a:avLst/>
+            <a:gdLst/>
+            <a:ahLst/>
+            <a:cxnLst/>
+            <a:rect l="l" t="t" r="r" b="b"/>
+            <a:pathLst>
+              <a:path w="3860800" h="2126010">
+                <a:moveTo>
+                  <a:pt x="0" y="76200"/>
+                </a:moveTo>
+                <a:lnTo>
+                  <a:pt x="0" y="76200"/>
+                </a:lnTo>
+                <a:arcTo wR="76200" hR="76200" stAng="10800000" swAng="5400000"/>
+                <a:lnTo>
+                  <a:pt x="3784600" y="0"/>
+                </a:lnTo>
+                <a:arcTo wR="76200" hR="76200" stAng="16200000" swAng="5400000"/>
+                <a:lnTo>
+                  <a:pt x="3860800" y="76200"/>
+                </a:lnTo>
+                <a:arcTo wR="76200" hR="25400" stAng="0" swAng="-5400000"/>
+                <a:lnTo>
+                  <a:pt x="76200" y="50800"/>
+                </a:lnTo>
+                <a:arcTo wR="76200" hR="25400" stAng="16200000" swAng="-5400000"/>
+                <a:close/>
+              </a:path>
+            </a:pathLst>
+          </a:custGeom>
+          <a:solidFill>
+            <a:srgbClr val="2D6A4F"/>
+          </a:solidFill>
+          <a:ln/>
+        </p:spPr>
+        <p:txBody>
+          <a:bodyPr/>
+          <a:lstStyle/>
+          <a:p>
+            <a:endParaRPr lang="pt-PT"/>
+          </a:p>
+        </p:txBody>
+      </p:sp>
+      <p:sp>
+        <p:nvSpPr>
+          <p:cNvPr id="24" name="Text 22"/>
+          <p:cNvSpPr/>
+          <p:nvPr/>
+        </p:nvSpPr>
+        <p:spPr>
+          <a:xfrm>
+            <a:off x="3695700" y="3919190"/>
+            <a:ext cx="3584194" cy="254000"/>
+          </a:xfrm>
+          <a:prstGeom prst="rect">
+            <a:avLst/>
+          </a:prstGeom>
+          <a:noFill/>
+          <a:ln/>
+        </p:spPr>
+        <p:txBody>
+          <a:bodyPr wrap="square" lIns="0" tIns="0" rIns="0" bIns="0" rtlCol="0" anchor="t">
+            <a:normAutofit/>
+          </a:bodyPr>
+          <a:lstStyle/>
+          <a:p>
+            <a:pPr marL="0" indent="0" algn="l">
+              <a:lnSpc>
+                <a:spcPts val="1800"/>
+              </a:lnSpc>
+              <a:buNone/>
+            </a:pPr>
+            <a:r>
+              <a:rPr lang="en-US" sz="1500" b="1" dirty="0">
+                <a:solidFill>
+                  <a:srgbClr val="2D6A4F"/>
+                </a:solidFill>
+                <a:latin typeface="Inter" pitchFamily="34" charset="0"/>
+                <a:ea typeface="Inter" pitchFamily="34" charset="-122"/>
+                <a:cs typeface="Inter" pitchFamily="34" charset="-120"/>
+              </a:rPr>
+              <a:t>Canais</a:t>
+            </a:r>
+            <a:endParaRPr lang="en-US" sz="1500" dirty="0"/>
+          </a:p>
+        </p:txBody>
+      </p:sp>
+      <p:sp>
+        <p:nvSpPr>
+          <p:cNvPr id="25" name="Text 23"/>
+          <p:cNvSpPr/>
+          <p:nvPr/>
+        </p:nvSpPr>
+        <p:spPr>
+          <a:xfrm>
+            <a:off x="3695700" y="4211290"/>
+            <a:ext cx="3584194" cy="215900"/>
+          </a:xfrm>
+          <a:prstGeom prst="rect">
+            <a:avLst/>
+          </a:prstGeom>
+          <a:noFill/>
+          <a:ln/>
+        </p:spPr>
+        <p:txBody>
+          <a:bodyPr wrap="square" lIns="0" tIns="0" rIns="0" bIns="0" rtlCol="0" anchor="t">
+            <a:normAutofit/>
+          </a:bodyPr>
+          <a:lstStyle/>
+          <a:p>
+            <a:pPr marL="0" indent="0" algn="l">
+              <a:lnSpc>
+                <a:spcPts val="1500"/>
+              </a:lnSpc>
+              <a:buNone/>
+            </a:pPr>
+            <a:r>
+              <a:rPr lang="en-US" sz="1200" b="1" dirty="0">
+                <a:solidFill>
+                  <a:srgbClr val="1E2B24"/>
+                </a:solidFill>
+                <a:latin typeface="Inter" pitchFamily="34" charset="0"/>
+                <a:ea typeface="Inter" pitchFamily="34" charset="-122"/>
+                <a:cs typeface="Inter" pitchFamily="34" charset="-120"/>
+              </a:rPr>
+              <a:t>Conhecer:</a:t>
+            </a:r>
+            <a:r>
+              <a:rPr lang="en-US" sz="1200" dirty="0">
+                <a:solidFill>
+                  <a:srgbClr val="1E2B24"/>
+                </a:solidFill>
+                <a:latin typeface="Inter" pitchFamily="34" charset="0"/>
+                <a:ea typeface="Inter" pitchFamily="34" charset="-122"/>
+                <a:cs typeface="Inter" pitchFamily="34" charset="-120"/>
+              </a:rPr>
+              <a:t> juntas, feiras e redes sociais</a:t>
+            </a:r>
+            <a:endParaRPr lang="en-US" sz="1200" dirty="0"/>
+          </a:p>
+        </p:txBody>
+      </p:sp>
+      <p:sp>
+        <p:nvSpPr>
+          <p:cNvPr id="26" name="Text 24"/>
+          <p:cNvSpPr/>
+          <p:nvPr/>
+        </p:nvSpPr>
+        <p:spPr>
+          <a:xfrm>
+            <a:off x="3695700" y="4465290"/>
+            <a:ext cx="3584194" cy="215900"/>
+          </a:xfrm>
+          <a:prstGeom prst="rect">
+            <a:avLst/>
+          </a:prstGeom>
+          <a:noFill/>
+          <a:ln/>
+        </p:spPr>
+        <p:txBody>
+          <a:bodyPr wrap="square" lIns="0" tIns="0" rIns="0" bIns="0" rtlCol="0" anchor="t">
+            <a:normAutofit/>
+          </a:bodyPr>
+          <a:lstStyle/>
+          <a:p>
+            <a:pPr marL="0" indent="0" algn="l">
+              <a:lnSpc>
+                <a:spcPts val="1500"/>
+              </a:lnSpc>
+              <a:buNone/>
+            </a:pPr>
+            <a:r>
+              <a:rPr lang="en-US" sz="1200" b="1" dirty="0">
+                <a:solidFill>
+                  <a:srgbClr val="1E2B24"/>
+                </a:solidFill>
+                <a:latin typeface="Inter" pitchFamily="34" charset="0"/>
+                <a:ea typeface="Inter" pitchFamily="34" charset="-122"/>
+                <a:cs typeface="Inter" pitchFamily="34" charset="-120"/>
+              </a:rPr>
+              <a:t>Comprar:</a:t>
+            </a:r>
+            <a:r>
+              <a:rPr lang="en-US" sz="1200" dirty="0">
+                <a:solidFill>
+                  <a:srgbClr val="1E2B24"/>
+                </a:solidFill>
+                <a:latin typeface="Inter" pitchFamily="34" charset="0"/>
+                <a:ea typeface="Inter" pitchFamily="34" charset="-122"/>
+                <a:cs typeface="Inter" pitchFamily="34" charset="-120"/>
+              </a:rPr>
+              <a:t> app com mapa e reserva</a:t>
+            </a:r>
+            <a:endParaRPr lang="en-US" sz="1200" dirty="0"/>
+          </a:p>
+        </p:txBody>
+      </p:sp>
+      <p:sp>
+        <p:nvSpPr>
+          <p:cNvPr id="27" name="Text 25"/>
+          <p:cNvSpPr/>
+          <p:nvPr/>
+        </p:nvSpPr>
+        <p:spPr>
+          <a:xfrm>
+            <a:off x="3695700" y="4719290"/>
+            <a:ext cx="3584194" cy="406400"/>
+          </a:xfrm>
+          <a:prstGeom prst="rect">
+            <a:avLst/>
+          </a:prstGeom>
+          <a:noFill/>
+          <a:ln/>
+        </p:spPr>
+        <p:txBody>
+          <a:bodyPr wrap="square" lIns="0" tIns="0" rIns="0" bIns="0" rtlCol="0" anchor="t">
+            <a:normAutofit/>
+          </a:bodyPr>
+          <a:lstStyle/>
+          <a:p>
+            <a:pPr marL="0" indent="0" algn="l">
+              <a:lnSpc>
+                <a:spcPts val="1500"/>
+              </a:lnSpc>
+              <a:buNone/>
+            </a:pPr>
+            <a:r>
+              <a:rPr lang="en-US" sz="1200" b="1" dirty="0">
+                <a:solidFill>
+                  <a:srgbClr val="1E2B24"/>
+                </a:solidFill>
+                <a:latin typeface="Inter" pitchFamily="34" charset="0"/>
+                <a:ea typeface="Inter" pitchFamily="34" charset="-122"/>
+                <a:cs typeface="Inter" pitchFamily="34" charset="-120"/>
+              </a:rPr>
+              <a:t>Receber:</a:t>
+            </a:r>
+            <a:r>
+              <a:rPr lang="en-US" sz="1200" dirty="0">
+                <a:solidFill>
+                  <a:srgbClr val="1E2B24"/>
+                </a:solidFill>
+                <a:latin typeface="Inter" pitchFamily="34" charset="0"/>
+                <a:ea typeface="Inter" pitchFamily="34" charset="-122"/>
+                <a:cs typeface="Inter" pitchFamily="34" charset="-120"/>
+              </a:rPr>
+              <a:t> recolha no produtor ou em ponto partilhado</a:t>
+            </a:r>
+            <a:endParaRPr lang="en-US" sz="1200" dirty="0"/>
+          </a:p>
+        </p:txBody>
+      </p:sp>
+      <p:sp>
+        <p:nvSpPr>
+          <p:cNvPr id="28" name="Text 26"/>
+          <p:cNvSpPr/>
+          <p:nvPr/>
+        </p:nvSpPr>
+        <p:spPr>
+          <a:xfrm>
+            <a:off x="3695700" y="5163790"/>
+            <a:ext cx="3584194" cy="215900"/>
+          </a:xfrm>
+          <a:prstGeom prst="rect">
+            <a:avLst/>
+          </a:prstGeom>
+          <a:noFill/>
+          <a:ln/>
+        </p:spPr>
+        <p:txBody>
+          <a:bodyPr wrap="square" lIns="0" tIns="0" rIns="0" bIns="0" rtlCol="0" anchor="t">
+            <a:normAutofit/>
+          </a:bodyPr>
+          <a:lstStyle/>
+          <a:p>
+            <a:pPr marL="0" indent="0" algn="l">
+              <a:lnSpc>
+                <a:spcPts val="1500"/>
+              </a:lnSpc>
+              <a:buNone/>
+            </a:pPr>
+            <a:r>
+              <a:rPr lang="en-US" sz="1200" b="1" dirty="0">
+                <a:solidFill>
+                  <a:srgbClr val="1E2B24"/>
+                </a:solidFill>
+                <a:latin typeface="Inter" pitchFamily="34" charset="0"/>
+                <a:ea typeface="Inter" pitchFamily="34" charset="-122"/>
+                <a:cs typeface="Inter" pitchFamily="34" charset="-120"/>
+              </a:rPr>
+              <a:t>Voltar:</a:t>
+            </a:r>
+            <a:r>
+              <a:rPr lang="en-US" sz="1200" dirty="0">
+                <a:solidFill>
+                  <a:srgbClr val="1E2B24"/>
+                </a:solidFill>
+                <a:latin typeface="Inter" pitchFamily="34" charset="0"/>
+                <a:ea typeface="Inter" pitchFamily="34" charset="-122"/>
+                <a:cs typeface="Inter" pitchFamily="34" charset="-120"/>
+              </a:rPr>
+              <a:t> favoritos e alertas “avisar-me”</a:t>
+            </a:r>
+            <a:endParaRPr lang="en-US" sz="1200" dirty="0"/>
+          </a:p>
+        </p:txBody>
+      </p:sp>
+      <p:sp>
+        <p:nvSpPr>
+          <p:cNvPr id="29" name="Shape 27"/>
+          <p:cNvSpPr/>
+          <p:nvPr/>
+        </p:nvSpPr>
+        <p:spPr>
+          <a:xfrm>
+            <a:off x="7518400" y="3715990"/>
+            <a:ext cx="3860800" cy="2126010"/>
+          </a:xfrm>
+          <a:prstGeom prst="roundRect">
+            <a:avLst>
+              <a:gd name="adj" fmla="val 3584"/>
+            </a:avLst>
+          </a:prstGeom>
+          <a:solidFill>
+            <a:srgbClr val="F5E3D6"/>
+          </a:solidFill>
+          <a:ln/>
+        </p:spPr>
+        <p:txBody>
+          <a:bodyPr/>
+          <a:lstStyle/>
+          <a:p>
+            <a:endParaRPr lang="pt-PT"/>
+          </a:p>
+        </p:txBody>
+      </p:sp>
+      <p:sp>
+        <p:nvSpPr>
+          <p:cNvPr id="30" name="Shape 28"/>
+          <p:cNvSpPr/>
+          <p:nvPr/>
+        </p:nvSpPr>
+        <p:spPr>
+          <a:xfrm>
+            <a:off x="7518400" y="3715990"/>
+            <a:ext cx="3860800" cy="2126010"/>
+          </a:xfrm>
+          <a:custGeom>
+            <a:avLst/>
+            <a:gdLst/>
+            <a:ahLst/>
+            <a:cxnLst/>
+            <a:rect l="l" t="t" r="r" b="b"/>
+            <a:pathLst>
+              <a:path w="3860800" h="2126010">
+                <a:moveTo>
+                  <a:pt x="0" y="76200"/>
+                </a:moveTo>
+                <a:lnTo>
+                  <a:pt x="0" y="76200"/>
+                </a:lnTo>
+                <a:arcTo wR="76200" hR="76200" stAng="10800000" swAng="5400000"/>
+                <a:lnTo>
+                  <a:pt x="3784600" y="0"/>
+                </a:lnTo>
+                <a:arcTo wR="76200" hR="76200" stAng="16200000" swAng="5400000"/>
+                <a:lnTo>
+                  <a:pt x="3860800" y="76200"/>
+                </a:lnTo>
+                <a:arcTo wR="76200" hR="25400" stAng="0" swAng="-5400000"/>
+                <a:lnTo>
+                  <a:pt x="76200" y="50800"/>
+                </a:lnTo>
+                <a:arcTo wR="76200" hR="25400" stAng="16200000" swAng="-5400000"/>
+                <a:close/>
+              </a:path>
+            </a:pathLst>
+          </a:custGeom>
+          <a:solidFill>
+            <a:srgbClr val="C5703C"/>
+          </a:solidFill>
+          <a:ln/>
+        </p:spPr>
+        <p:txBody>
+          <a:bodyPr/>
+          <a:lstStyle/>
+          <a:p>
+            <a:endParaRPr lang="pt-PT"/>
+          </a:p>
+        </p:txBody>
+      </p:sp>
+      <p:sp>
+        <p:nvSpPr>
+          <p:cNvPr id="31" name="Text 29"/>
+          <p:cNvSpPr/>
+          <p:nvPr/>
+        </p:nvSpPr>
+        <p:spPr>
+          <a:xfrm>
+            <a:off x="7708900" y="3919190"/>
+            <a:ext cx="3584194" cy="254000"/>
+          </a:xfrm>
+          <a:prstGeom prst="rect">
+            <a:avLst/>
+          </a:prstGeom>
+          <a:noFill/>
+          <a:ln/>
+        </p:spPr>
+        <p:txBody>
+          <a:bodyPr wrap="square" lIns="0" tIns="0" rIns="0" bIns="0" rtlCol="0" anchor="t">
+            <a:normAutofit/>
+          </a:bodyPr>
+          <a:lstStyle/>
+          <a:p>
+            <a:pPr marL="0" indent="0" algn="l">
+              <a:lnSpc>
+                <a:spcPts val="1800"/>
+              </a:lnSpc>
+              <a:buNone/>
+            </a:pPr>
+            <a:r>
+              <a:rPr lang="en-US" sz="1500" b="1" dirty="0">
+                <a:solidFill>
+                  <a:srgbClr val="A85A2A"/>
+                </a:solidFill>
+                <a:latin typeface="Inter" pitchFamily="34" charset="0"/>
+                <a:ea typeface="Inter" pitchFamily="34" charset="-122"/>
+                <a:cs typeface="Inter" pitchFamily="34" charset="-120"/>
+              </a:rPr>
+              <a:t>Fontes de receita</a:t>
+            </a:r>
+            <a:endParaRPr lang="en-US" sz="1500" dirty="0"/>
+          </a:p>
+        </p:txBody>
+      </p:sp>
+      <p:sp>
+        <p:nvSpPr>
+          <p:cNvPr id="32" name="Text 30"/>
+          <p:cNvSpPr/>
+          <p:nvPr/>
+        </p:nvSpPr>
+        <p:spPr>
+          <a:xfrm>
+            <a:off x="7708900" y="4223990"/>
+            <a:ext cx="3584194" cy="360660"/>
+          </a:xfrm>
+          <a:prstGeom prst="rect">
+            <a:avLst/>
+          </a:prstGeom>
+          <a:noFill/>
+          <a:ln/>
+        </p:spPr>
+        <p:txBody>
+          <a:bodyPr wrap="square" lIns="0" tIns="0" rIns="0" bIns="0" rtlCol="0" anchor="t">
+            <a:normAutofit/>
+          </a:bodyPr>
+          <a:lstStyle/>
+          <a:p>
+            <a:pPr marL="0" indent="0" algn="l">
+              <a:lnSpc>
+                <a:spcPts val="2640"/>
+              </a:lnSpc>
+              <a:buNone/>
+            </a:pPr>
+            <a:r>
+              <a:rPr lang="en-US" sz="2400" b="1" dirty="0">
+                <a:solidFill>
+                  <a:srgbClr val="1E2B24"/>
+                </a:solidFill>
+                <a:latin typeface="Inter" pitchFamily="34" charset="0"/>
+                <a:ea typeface="Inter" pitchFamily="34" charset="-122"/>
+                <a:cs typeface="Inter" pitchFamily="34" charset="-120"/>
+              </a:rPr>
+              <a:t>0,50 € + 5 %</a:t>
+            </a:r>
+            <a:endParaRPr lang="en-US" sz="2400" dirty="0"/>
+          </a:p>
+        </p:txBody>
+      </p:sp>
+      <p:sp>
+        <p:nvSpPr>
+          <p:cNvPr id="33" name="Text 31"/>
+          <p:cNvSpPr/>
+          <p:nvPr/>
+        </p:nvSpPr>
+        <p:spPr>
+          <a:xfrm>
+            <a:off x="7708900" y="4635450"/>
+            <a:ext cx="3584194" cy="406400"/>
+          </a:xfrm>
+          <a:prstGeom prst="rect">
+            <a:avLst/>
+          </a:prstGeom>
+          <a:noFill/>
+          <a:ln/>
+        </p:spPr>
+        <p:txBody>
+          <a:bodyPr wrap="square" lIns="0" tIns="0" rIns="0" bIns="0" rtlCol="0" anchor="t">
+            <a:normAutofit/>
+          </a:bodyPr>
+          <a:lstStyle/>
+          <a:p>
+            <a:pPr marL="0" indent="0" algn="l">
+              <a:lnSpc>
+                <a:spcPts val="1500"/>
+              </a:lnSpc>
+              <a:buNone/>
+            </a:pPr>
+            <a:r>
+              <a:rPr lang="en-US" sz="1200" dirty="0">
+                <a:solidFill>
+                  <a:srgbClr val="1E2B24"/>
+                </a:solidFill>
+                <a:latin typeface="Inter" pitchFamily="34" charset="0"/>
+                <a:ea typeface="Inter" pitchFamily="34" charset="-122"/>
+                <a:cs typeface="Inter" pitchFamily="34" charset="-120"/>
+              </a:rPr>
+              <a:t>por compra, pago pelo comprador; </a:t>
+            </a:r>
+            <a:r>
+              <a:rPr lang="en-US" sz="1200" b="1" dirty="0">
+                <a:solidFill>
+                  <a:srgbClr val="1E2B24"/>
+                </a:solidFill>
+                <a:latin typeface="Inter" pitchFamily="34" charset="0"/>
+                <a:ea typeface="Inter" pitchFamily="34" charset="-122"/>
+                <a:cs typeface="Inter" pitchFamily="34" charset="-120"/>
+              </a:rPr>
+              <a:t>vender é grátis</a:t>
+            </a:r>
+            <a:endParaRPr lang="en-US" sz="1200" dirty="0"/>
+          </a:p>
+        </p:txBody>
+      </p:sp>
+      <p:sp>
+        <p:nvSpPr>
+          <p:cNvPr id="34" name="Text 32"/>
+          <p:cNvSpPr/>
+          <p:nvPr/>
+        </p:nvSpPr>
+        <p:spPr>
+          <a:xfrm>
+            <a:off x="7708900" y="5092650"/>
+            <a:ext cx="3584194" cy="406400"/>
+          </a:xfrm>
+          <a:prstGeom prst="rect">
+            <a:avLst/>
+          </a:prstGeom>
+          <a:noFill/>
+          <a:ln/>
+        </p:spPr>
+        <p:txBody>
+          <a:bodyPr wrap="square" lIns="0" tIns="0" rIns="0" bIns="0" rtlCol="0" anchor="t">
+            <a:normAutofit/>
+          </a:bodyPr>
+          <a:lstStyle/>
+          <a:p>
+            <a:pPr marL="0" indent="0" algn="l">
+              <a:lnSpc>
+                <a:spcPts val="1500"/>
+              </a:lnSpc>
+              <a:buNone/>
+            </a:pPr>
+            <a:r>
+              <a:rPr lang="en-US" sz="1200" b="1" dirty="0">
+                <a:solidFill>
+                  <a:srgbClr val="1E2B24"/>
+                </a:solidFill>
+                <a:latin typeface="Inter" pitchFamily="34" charset="0"/>
+                <a:ea typeface="Inter" pitchFamily="34" charset="-122"/>
+                <a:cs typeface="Inter" pitchFamily="34" charset="-120"/>
+              </a:rPr>
+              <a:t>Extra:</a:t>
+            </a:r>
+            <a:r>
+              <a:rPr lang="en-US" sz="1200" dirty="0">
+                <a:solidFill>
+                  <a:srgbClr val="1E2B24"/>
+                </a:solidFill>
+                <a:latin typeface="Inter" pitchFamily="34" charset="0"/>
+                <a:ea typeface="Inter" pitchFamily="34" charset="-122"/>
+                <a:cs typeface="Inter" pitchFamily="34" charset="-120"/>
+              </a:rPr>
+              <a:t> destaque no mapa · </a:t>
+            </a:r>
+            <a:r>
+              <a:rPr lang="en-US" sz="1200" b="1" dirty="0">
+                <a:solidFill>
+                  <a:srgbClr val="1E2B24"/>
+                </a:solidFill>
+                <a:latin typeface="Inter" pitchFamily="34" charset="0"/>
+                <a:ea typeface="Inter" pitchFamily="34" charset="-122"/>
+                <a:cs typeface="Inter" pitchFamily="34" charset="-120"/>
+              </a:rPr>
+              <a:t>Fase 2:</a:t>
+            </a:r>
+            <a:r>
+              <a:rPr lang="en-US" sz="1200" dirty="0">
+                <a:solidFill>
+                  <a:srgbClr val="1E2B24"/>
+                </a:solidFill>
+                <a:latin typeface="Inter" pitchFamily="34" charset="0"/>
+                <a:ea typeface="Inter" pitchFamily="34" charset="-122"/>
+                <a:cs typeface="Inter" pitchFamily="34" charset="-120"/>
+              </a:rPr>
+              <a:t> GrowNear Pro</a:t>
+            </a:r>
+            <a:endParaRPr lang="en-US" sz="1200" dirty="0"/>
+          </a:p>
+        </p:txBody>
+      </p:sp>
+      <p:sp>
+        <p:nvSpPr>
+          <p:cNvPr id="35" name="Text 33"/>
+          <p:cNvSpPr/>
+          <p:nvPr/>
+        </p:nvSpPr>
+        <p:spPr>
+          <a:xfrm>
+            <a:off x="812800" y="6238280"/>
+            <a:ext cx="914281" cy="238720"/>
+          </a:xfrm>
+          <a:prstGeom prst="rect">
+            <a:avLst/>
+          </a:prstGeom>
+          <a:noFill/>
+          <a:ln/>
+        </p:spPr>
+        <p:txBody>
+          <a:bodyPr wrap="square" lIns="0" tIns="0" rIns="0" bIns="0" rtlCol="0" anchor="t">
+            <a:normAutofit/>
+          </a:bodyPr>
+          <a:lstStyle/>
+          <a:p>
+            <a:pPr marL="0" indent="0" algn="l">
+              <a:lnSpc>
+                <a:spcPts val="1680"/>
+              </a:lnSpc>
+              <a:buNone/>
+            </a:pPr>
+            <a:r>
+              <a:rPr lang="en-US" sz="1200" b="1" dirty="0">
+                <a:solidFill>
+                  <a:srgbClr val="2D6A4F"/>
+                </a:solidFill>
+                <a:latin typeface="Inter" pitchFamily="34" charset="0"/>
+                <a:ea typeface="Inter" pitchFamily="34" charset="-122"/>
+                <a:cs typeface="Inter" pitchFamily="34" charset="-120"/>
+              </a:rPr>
+              <a:t>GrowNear</a:t>
+            </a:r>
+            <a:endParaRPr lang="en-US" sz="1200" dirty="0"/>
+          </a:p>
+        </p:txBody>
+      </p:sp>
+      <p:sp>
+        <p:nvSpPr>
+          <p:cNvPr id="36" name="Text 34"/>
+          <p:cNvSpPr/>
+          <p:nvPr/>
+        </p:nvSpPr>
+        <p:spPr>
+          <a:xfrm>
+            <a:off x="10058400" y="6238280"/>
+            <a:ext cx="1320800" cy="238720"/>
+          </a:xfrm>
+          <a:prstGeom prst="rect">
+            <a:avLst/>
+          </a:prstGeom>
+          <a:noFill/>
+          <a:ln/>
+        </p:spPr>
+        <p:txBody>
+          <a:bodyPr wrap="square" lIns="0" tIns="0" rIns="0" bIns="0" rtlCol="0" anchor="t">
+            <a:normAutofit/>
+          </a:bodyPr>
+          <a:lstStyle/>
+          <a:p>
+            <a:pPr marL="0" indent="0" algn="r">
+              <a:lnSpc>
+                <a:spcPts val="1680"/>
+              </a:lnSpc>
+              <a:buNone/>
+            </a:pPr>
+            <a:r>
+              <a:rPr lang="en-US" sz="1200" dirty="0">
+                <a:solidFill>
+                  <a:srgbClr val="6B776F"/>
+                </a:solidFill>
+                <a:latin typeface="Inter" pitchFamily="34" charset="0"/>
+                <a:ea typeface="Inter" pitchFamily="34" charset="-122"/>
+                <a:cs typeface="Inter" pitchFamily="34" charset="-120"/>
+              </a:rPr>
+              <a:t>4</a:t>
+            </a:r>
+            <a:endParaRPr lang="en-US" sz="1200" dirty="0"/>
+          </a:p>
+        </p:txBody>
+      </p:sp>
+    </p:spTree>
+  </p:cSld>
+  <p:clrMapOvr>
+    <a:masterClrMapping/>
+  </p:clrMapOvr>
+</p:sld>
+</file>
+
+<file path=ppt/slides/slide5.xml><?xml version="1.0" encoding="utf-8"?>
 <p:sld xmlns:a="http://schemas.openxmlformats.org/drawingml/2006/main" xmlns:r="http://schemas.openxmlformats.org/officeDocument/2006/relationships" xmlns:p="http://schemas.openxmlformats.org/presentationml/2006/main">
   <p:cSld name="Slide 4">
     <p:bg>
@@ -5532,1754 +7334,6 @@
       <p:sp>
         <p:nvSpPr>
           <p:cNvPr id="35" name="Text 33"/>
-          <p:cNvSpPr/>
-          <p:nvPr/>
-        </p:nvSpPr>
-        <p:spPr>
-          <a:xfrm>
-            <a:off x="10058400" y="6238280"/>
-            <a:ext cx="1320800" cy="238720"/>
-          </a:xfrm>
-          <a:prstGeom prst="rect">
-            <a:avLst/>
-          </a:prstGeom>
-          <a:noFill/>
-          <a:ln/>
-        </p:spPr>
-        <p:txBody>
-          <a:bodyPr wrap="square" lIns="0" tIns="0" rIns="0" bIns="0" rtlCol="0" anchor="t">
-            <a:normAutofit/>
-          </a:bodyPr>
-          <a:lstStyle/>
-          <a:p>
-            <a:pPr marL="0" indent="0" algn="r">
-              <a:lnSpc>
-                <a:spcPts val="1680"/>
-              </a:lnSpc>
-              <a:buNone/>
-            </a:pPr>
-            <a:r>
-              <a:rPr lang="en-US" sz="1200" dirty="0">
-                <a:solidFill>
-                  <a:srgbClr val="6B776F"/>
-                </a:solidFill>
-                <a:latin typeface="Inter" pitchFamily="34" charset="0"/>
-                <a:ea typeface="Inter" pitchFamily="34" charset="-122"/>
-                <a:cs typeface="Inter" pitchFamily="34" charset="-120"/>
-              </a:rPr>
-              <a:t>4</a:t>
-            </a:r>
-            <a:endParaRPr lang="en-US" sz="1200" dirty="0"/>
-          </a:p>
-        </p:txBody>
-      </p:sp>
-    </p:spTree>
-  </p:cSld>
-  <p:clrMapOvr>
-    <a:masterClrMapping/>
-  </p:clrMapOvr>
-</p:sld>
-</file>
-
-<file path=ppt/slides/slide5.xml><?xml version="1.0" encoding="utf-8"?>
-<p:sld xmlns:a="http://schemas.openxmlformats.org/drawingml/2006/main" xmlns:r="http://schemas.openxmlformats.org/officeDocument/2006/relationships" xmlns:p="http://schemas.openxmlformats.org/presentationml/2006/main">
-  <p:cSld name="Slide 5">
-    <p:bg>
-      <p:bgPr>
-        <a:solidFill>
-          <a:srgbClr val="F7F3EC"/>
-        </a:solidFill>
-        <a:effectLst/>
-      </p:bgPr>
-    </p:bg>
-    <p:spTree>
-      <p:nvGrpSpPr>
-        <p:cNvPr id="1" name=""/>
-        <p:cNvGrpSpPr/>
-        <p:nvPr/>
-      </p:nvGrpSpPr>
-      <p:grpSpPr>
-        <a:xfrm>
-          <a:off x="0" y="0"/>
-          <a:ext cx="0" cy="0"/>
-          <a:chOff x="0" y="0"/>
-          <a:chExt cx="0" cy="0"/>
-        </a:xfrm>
-      </p:grpSpPr>
-      <p:sp>
-        <p:nvSpPr>
-          <p:cNvPr id="2" name="Text 0"/>
-          <p:cNvSpPr>
-            <a:spLocks noGrp="1"/>
-          </p:cNvSpPr>
-          <p:nvPr>
-            <p:ph type="title"/>
-          </p:nvPr>
-        </p:nvSpPr>
-        <p:spPr>
-          <a:xfrm>
-            <a:off x="812800" y="812800"/>
-            <a:ext cx="5669399" cy="472430"/>
-          </a:xfrm>
-          <a:prstGeom prst="rect">
-            <a:avLst/>
-          </a:prstGeom>
-          <a:noFill/>
-          <a:ln/>
-        </p:spPr>
-        <p:txBody>
-          <a:bodyPr wrap="square" lIns="0" tIns="0" rIns="0" bIns="0" rtlCol="0" anchor="t">
-            <a:normAutofit/>
-          </a:bodyPr>
-          <a:lstStyle/>
-          <a:p>
-            <a:pPr marL="0" indent="0" algn="l">
-              <a:lnSpc>
-                <a:spcPts val="3520"/>
-              </a:lnSpc>
-              <a:buNone/>
-            </a:pPr>
-            <a:r>
-              <a:rPr lang="en-US" sz="3200" b="1" i="0" dirty="0">
-                <a:solidFill>
-                  <a:srgbClr val="2D6A4F"/>
-                </a:solidFill>
-                <a:latin typeface="Inter" pitchFamily="34" charset="0"/>
-                <a:ea typeface="Inter" pitchFamily="34" charset="-122"/>
-                <a:cs typeface="Inter" pitchFamily="34" charset="-120"/>
-              </a:rPr>
-              <a:t>Business Model Canvas</a:t>
-            </a:r>
-            <a:endParaRPr lang="en-US" sz="3200" dirty="0"/>
-          </a:p>
-        </p:txBody>
-      </p:sp>
-      <p:sp>
-        <p:nvSpPr>
-          <p:cNvPr id="3" name="Text 1"/>
-          <p:cNvSpPr/>
-          <p:nvPr/>
-        </p:nvSpPr>
-        <p:spPr>
-          <a:xfrm>
-            <a:off x="9695607" y="909340"/>
-            <a:ext cx="1683593" cy="350490"/>
-          </a:xfrm>
-          <a:prstGeom prst="roundRect">
-            <a:avLst>
-              <a:gd name="adj" fmla="val 43482"/>
-            </a:avLst>
-          </a:prstGeom>
-          <a:solidFill>
-            <a:srgbClr val="C5703C"/>
-          </a:solidFill>
-          <a:ln/>
-        </p:spPr>
-        <p:txBody>
-          <a:bodyPr wrap="none" lIns="0" tIns="0" rIns="0" bIns="0" rtlCol="0" anchor="ctr">
-            <a:normAutofit/>
-          </a:bodyPr>
-          <a:lstStyle/>
-          <a:p>
-            <a:pPr marL="0" indent="0" algn="ctr">
-              <a:lnSpc>
-                <a:spcPts val="1960"/>
-              </a:lnSpc>
-              <a:buNone/>
-            </a:pPr>
-            <a:r>
-              <a:rPr lang="en-US" sz="1400" b="1" kern="0" spc="100" dirty="0">
-                <a:solidFill>
-                  <a:srgbClr val="FFFDF9"/>
-                </a:solidFill>
-                <a:latin typeface="Inter" pitchFamily="34" charset="0"/>
-                <a:ea typeface="Inter" pitchFamily="34" charset="-122"/>
-                <a:cs typeface="Inter" pitchFamily="34" charset="-120"/>
-              </a:rPr>
-              <a:t>FRONT STAGE</a:t>
-            </a:r>
-            <a:endParaRPr lang="en-US" sz="1400" dirty="0"/>
-          </a:p>
-        </p:txBody>
-      </p:sp>
-      <p:sp>
-        <p:nvSpPr>
-          <p:cNvPr id="4" name="Shape 2"/>
-          <p:cNvSpPr/>
-          <p:nvPr/>
-        </p:nvSpPr>
-        <p:spPr>
-          <a:xfrm>
-            <a:off x="812800" y="1437630"/>
-            <a:ext cx="2540000" cy="4404370"/>
-          </a:xfrm>
-          <a:prstGeom prst="roundRect">
-            <a:avLst>
-              <a:gd name="adj" fmla="val 3000"/>
-            </a:avLst>
-          </a:prstGeom>
-          <a:solidFill>
-            <a:srgbClr val="2D6A4F"/>
-          </a:solidFill>
-          <a:ln/>
-        </p:spPr>
-        <p:txBody>
-          <a:bodyPr/>
-          <a:lstStyle/>
-          <a:p>
-            <a:endParaRPr lang="pt-PT"/>
-          </a:p>
-        </p:txBody>
-      </p:sp>
-      <p:sp>
-        <p:nvSpPr>
-          <p:cNvPr id="5" name="Text 3"/>
-          <p:cNvSpPr/>
-          <p:nvPr/>
-        </p:nvSpPr>
-        <p:spPr>
-          <a:xfrm>
-            <a:off x="1016000" y="2367409"/>
-            <a:ext cx="2197608" cy="254000"/>
-          </a:xfrm>
-          <a:prstGeom prst="rect">
-            <a:avLst/>
-          </a:prstGeom>
-          <a:noFill/>
-          <a:ln/>
-        </p:spPr>
-        <p:txBody>
-          <a:bodyPr wrap="square" lIns="0" tIns="0" rIns="0" bIns="0" rtlCol="0" anchor="t">
-            <a:normAutofit/>
-          </a:bodyPr>
-          <a:lstStyle/>
-          <a:p>
-            <a:pPr marL="0" indent="0" algn="l">
-              <a:lnSpc>
-                <a:spcPts val="1800"/>
-              </a:lnSpc>
-              <a:buNone/>
-            </a:pPr>
-            <a:r>
-              <a:rPr lang="en-US" sz="1500" b="1" dirty="0">
-                <a:solidFill>
-                  <a:srgbClr val="F3D2BC"/>
-                </a:solidFill>
-                <a:latin typeface="Inter" pitchFamily="34" charset="0"/>
-                <a:ea typeface="Inter" pitchFamily="34" charset="-122"/>
-                <a:cs typeface="Inter" pitchFamily="34" charset="-120"/>
-              </a:rPr>
-              <a:t>Proposta de valor</a:t>
-            </a:r>
-            <a:endParaRPr lang="en-US" sz="1500" dirty="0"/>
-          </a:p>
-        </p:txBody>
-      </p:sp>
-      <p:sp>
-        <p:nvSpPr>
-          <p:cNvPr id="6" name="Text 4"/>
-          <p:cNvSpPr/>
-          <p:nvPr/>
-        </p:nvSpPr>
-        <p:spPr>
-          <a:xfrm>
-            <a:off x="1016000" y="2773809"/>
-            <a:ext cx="2197608" cy="817761"/>
-          </a:xfrm>
-          <a:prstGeom prst="rect">
-            <a:avLst/>
-          </a:prstGeom>
-          <a:noFill/>
-          <a:ln/>
-        </p:spPr>
-        <p:txBody>
-          <a:bodyPr wrap="square" lIns="0" tIns="0" rIns="0" bIns="0" rtlCol="0" anchor="t">
-            <a:normAutofit/>
-          </a:bodyPr>
-          <a:lstStyle/>
-          <a:p>
-            <a:pPr marL="0" indent="0" algn="l">
-              <a:lnSpc>
-                <a:spcPts val="1560"/>
-              </a:lnSpc>
-              <a:buNone/>
-            </a:pPr>
-            <a:r>
-              <a:rPr lang="en-US" sz="1200" b="1" dirty="0">
-                <a:solidFill>
-                  <a:srgbClr val="FFFDF9"/>
-                </a:solidFill>
-                <a:latin typeface="Inter" pitchFamily="34" charset="0"/>
-                <a:ea typeface="Inter" pitchFamily="34" charset="-122"/>
-                <a:cs typeface="Inter" pitchFamily="34" charset="-120"/>
-              </a:rPr>
-              <a:t>Compradores:</a:t>
-            </a:r>
-            <a:r>
-              <a:rPr lang="en-US" sz="1200" dirty="0">
-                <a:solidFill>
-                  <a:srgbClr val="FFFDF9"/>
-                </a:solidFill>
-                <a:latin typeface="Inter" pitchFamily="34" charset="0"/>
-                <a:ea typeface="Inter" pitchFamily="34" charset="-122"/>
-                <a:cs typeface="Inter" pitchFamily="34" charset="-120"/>
-              </a:rPr>
-              <a:t> frescos e locais, perto de casa, com origem conhecida e pagamento seguro</a:t>
-            </a:r>
-            <a:endParaRPr lang="en-US" sz="1200" dirty="0"/>
-          </a:p>
-        </p:txBody>
-      </p:sp>
-      <p:sp>
-        <p:nvSpPr>
-          <p:cNvPr id="7" name="Text 5"/>
-          <p:cNvSpPr/>
-          <p:nvPr/>
-        </p:nvSpPr>
-        <p:spPr>
-          <a:xfrm>
-            <a:off x="1016000" y="3743970"/>
-            <a:ext cx="2197608" cy="619671"/>
-          </a:xfrm>
-          <a:prstGeom prst="rect">
-            <a:avLst/>
-          </a:prstGeom>
-          <a:noFill/>
-          <a:ln/>
-        </p:spPr>
-        <p:txBody>
-          <a:bodyPr wrap="square" lIns="0" tIns="0" rIns="0" bIns="0" rtlCol="0" anchor="t">
-            <a:normAutofit/>
-          </a:bodyPr>
-          <a:lstStyle/>
-          <a:p>
-            <a:pPr marL="0" indent="0" algn="l">
-              <a:lnSpc>
-                <a:spcPts val="1560"/>
-              </a:lnSpc>
-              <a:buNone/>
-            </a:pPr>
-            <a:r>
-              <a:rPr lang="en-US" sz="1200" b="1" dirty="0">
-                <a:solidFill>
-                  <a:srgbClr val="FFFDF9"/>
-                </a:solidFill>
-                <a:latin typeface="Inter" pitchFamily="34" charset="0"/>
-                <a:ea typeface="Inter" pitchFamily="34" charset="-122"/>
-                <a:cs typeface="Inter" pitchFamily="34" charset="-120"/>
-              </a:rPr>
-              <a:t>Vendedores:</a:t>
-            </a:r>
-            <a:r>
-              <a:rPr lang="en-US" sz="1200" dirty="0">
-                <a:solidFill>
-                  <a:srgbClr val="FFFDF9"/>
-                </a:solidFill>
-                <a:latin typeface="Inter" pitchFamily="34" charset="0"/>
-                <a:ea typeface="Inter" pitchFamily="34" charset="-122"/>
-                <a:cs typeface="Inter" pitchFamily="34" charset="-120"/>
-              </a:rPr>
-              <a:t> o excedente vira rendimento; anunciar é grátis</a:t>
-            </a:r>
-            <a:endParaRPr lang="en-US" sz="1200" dirty="0"/>
-          </a:p>
-        </p:txBody>
-      </p:sp>
-      <p:sp>
-        <p:nvSpPr>
-          <p:cNvPr id="8" name="Text 6"/>
-          <p:cNvSpPr/>
-          <p:nvPr/>
-        </p:nvSpPr>
-        <p:spPr>
-          <a:xfrm>
-            <a:off x="1016000" y="4516041"/>
-            <a:ext cx="2197608" cy="421580"/>
-          </a:xfrm>
-          <a:prstGeom prst="rect">
-            <a:avLst/>
-          </a:prstGeom>
-          <a:noFill/>
-          <a:ln/>
-        </p:spPr>
-        <p:txBody>
-          <a:bodyPr wrap="square" lIns="0" tIns="0" rIns="0" bIns="0" rtlCol="0" anchor="t">
-            <a:normAutofit/>
-          </a:bodyPr>
-          <a:lstStyle/>
-          <a:p>
-            <a:pPr marL="0" indent="0" algn="l">
-              <a:lnSpc>
-                <a:spcPts val="1560"/>
-              </a:lnSpc>
-              <a:buNone/>
-            </a:pPr>
-            <a:r>
-              <a:rPr lang="en-US" sz="1200" b="1" dirty="0">
-                <a:solidFill>
-                  <a:srgbClr val="FFFDF9"/>
-                </a:solidFill>
-                <a:latin typeface="Inter" pitchFamily="34" charset="0"/>
-                <a:ea typeface="Inter" pitchFamily="34" charset="-122"/>
-                <a:cs typeface="Inter" pitchFamily="34" charset="-120"/>
-              </a:rPr>
-              <a:t>Comunidade:</a:t>
-            </a:r>
-            <a:r>
-              <a:rPr lang="en-US" sz="1200" dirty="0">
-                <a:solidFill>
-                  <a:srgbClr val="FFFDF9"/>
-                </a:solidFill>
-                <a:latin typeface="Inter" pitchFamily="34" charset="0"/>
-                <a:ea typeface="Inter" pitchFamily="34" charset="-122"/>
-                <a:cs typeface="Inter" pitchFamily="34" charset="-120"/>
-              </a:rPr>
-              <a:t> menos desperdício e economia local</a:t>
-            </a:r>
-            <a:endParaRPr lang="en-US" sz="1200" dirty="0"/>
-          </a:p>
-        </p:txBody>
-      </p:sp>
-      <p:sp>
-        <p:nvSpPr>
-          <p:cNvPr id="9" name="Shape 7"/>
-          <p:cNvSpPr/>
-          <p:nvPr/>
-        </p:nvSpPr>
-        <p:spPr>
-          <a:xfrm>
-            <a:off x="3505200" y="1437630"/>
-            <a:ext cx="3860800" cy="2125960"/>
-          </a:xfrm>
-          <a:prstGeom prst="roundRect">
-            <a:avLst>
-              <a:gd name="adj" fmla="val 3584"/>
-            </a:avLst>
-          </a:prstGeom>
-          <a:solidFill>
-            <a:srgbClr val="FFFDF9"/>
-          </a:solidFill>
-          <a:ln/>
-        </p:spPr>
-        <p:txBody>
-          <a:bodyPr/>
-          <a:lstStyle/>
-          <a:p>
-            <a:endParaRPr lang="pt-PT"/>
-          </a:p>
-        </p:txBody>
-      </p:sp>
-      <p:sp>
-        <p:nvSpPr>
-          <p:cNvPr id="10" name="Shape 8"/>
-          <p:cNvSpPr/>
-          <p:nvPr/>
-        </p:nvSpPr>
-        <p:spPr>
-          <a:xfrm>
-            <a:off x="3505200" y="1437630"/>
-            <a:ext cx="3860800" cy="2125960"/>
-          </a:xfrm>
-          <a:custGeom>
-            <a:avLst/>
-            <a:gdLst/>
-            <a:ahLst/>
-            <a:cxnLst/>
-            <a:rect l="l" t="t" r="r" b="b"/>
-            <a:pathLst>
-              <a:path w="3860800" h="2125960">
-                <a:moveTo>
-                  <a:pt x="0" y="76200"/>
-                </a:moveTo>
-                <a:lnTo>
-                  <a:pt x="0" y="76200"/>
-                </a:lnTo>
-                <a:arcTo wR="76200" hR="76200" stAng="10800000" swAng="5400000"/>
-                <a:lnTo>
-                  <a:pt x="3784600" y="0"/>
-                </a:lnTo>
-                <a:arcTo wR="76200" hR="76200" stAng="16200000" swAng="5400000"/>
-                <a:lnTo>
-                  <a:pt x="3860800" y="76200"/>
-                </a:lnTo>
-                <a:arcTo wR="76200" hR="25400" stAng="0" swAng="-5400000"/>
-                <a:lnTo>
-                  <a:pt x="76200" y="50800"/>
-                </a:lnTo>
-                <a:arcTo wR="76200" hR="25400" stAng="16200000" swAng="-5400000"/>
-                <a:close/>
-              </a:path>
-            </a:pathLst>
-          </a:custGeom>
-          <a:solidFill>
-            <a:srgbClr val="2D6A4F"/>
-          </a:solidFill>
-          <a:ln/>
-        </p:spPr>
-        <p:txBody>
-          <a:bodyPr/>
-          <a:lstStyle/>
-          <a:p>
-            <a:endParaRPr lang="pt-PT"/>
-          </a:p>
-        </p:txBody>
-      </p:sp>
-      <p:sp>
-        <p:nvSpPr>
-          <p:cNvPr id="11" name="Text 9"/>
-          <p:cNvSpPr/>
-          <p:nvPr/>
-        </p:nvSpPr>
-        <p:spPr>
-          <a:xfrm>
-            <a:off x="3695700" y="1640830"/>
-            <a:ext cx="3584194" cy="254000"/>
-          </a:xfrm>
-          <a:prstGeom prst="rect">
-            <a:avLst/>
-          </a:prstGeom>
-          <a:noFill/>
-          <a:ln/>
-        </p:spPr>
-        <p:txBody>
-          <a:bodyPr wrap="square" lIns="0" tIns="0" rIns="0" bIns="0" rtlCol="0" anchor="t">
-            <a:normAutofit/>
-          </a:bodyPr>
-          <a:lstStyle/>
-          <a:p>
-            <a:pPr marL="0" indent="0" algn="l">
-              <a:lnSpc>
-                <a:spcPts val="1800"/>
-              </a:lnSpc>
-              <a:buNone/>
-            </a:pPr>
-            <a:r>
-              <a:rPr lang="en-US" sz="1500" b="1" dirty="0">
-                <a:solidFill>
-                  <a:srgbClr val="2D6A4F"/>
-                </a:solidFill>
-                <a:latin typeface="Inter" pitchFamily="34" charset="0"/>
-                <a:ea typeface="Inter" pitchFamily="34" charset="-122"/>
-                <a:cs typeface="Inter" pitchFamily="34" charset="-120"/>
-              </a:rPr>
-              <a:t>Segmentos de clientes</a:t>
-            </a:r>
-            <a:endParaRPr lang="en-US" sz="1500" dirty="0"/>
-          </a:p>
-        </p:txBody>
-      </p:sp>
-      <p:sp>
-        <p:nvSpPr>
-          <p:cNvPr id="12" name="Text 10"/>
-          <p:cNvSpPr/>
-          <p:nvPr/>
-        </p:nvSpPr>
-        <p:spPr>
-          <a:xfrm>
-            <a:off x="3695700" y="1932930"/>
-            <a:ext cx="3584194" cy="406400"/>
-          </a:xfrm>
-          <a:prstGeom prst="rect">
-            <a:avLst/>
-          </a:prstGeom>
-          <a:noFill/>
-          <a:ln/>
-        </p:spPr>
-        <p:txBody>
-          <a:bodyPr wrap="square" lIns="0" tIns="0" rIns="0" bIns="0" rtlCol="0" anchor="t">
-            <a:normAutofit/>
-          </a:bodyPr>
-          <a:lstStyle/>
-          <a:p>
-            <a:pPr marL="0" indent="0" algn="l">
-              <a:lnSpc>
-                <a:spcPts val="1500"/>
-              </a:lnSpc>
-              <a:buNone/>
-            </a:pPr>
-            <a:r>
-              <a:rPr lang="en-US" sz="1200" b="1" dirty="0">
-                <a:solidFill>
-                  <a:srgbClr val="1E2B24"/>
-                </a:solidFill>
-                <a:latin typeface="Inter" pitchFamily="34" charset="0"/>
-                <a:ea typeface="Inter" pitchFamily="34" charset="-122"/>
-                <a:cs typeface="Inter" pitchFamily="34" charset="-120"/>
-              </a:rPr>
-              <a:t>Multilateral:</a:t>
-            </a:r>
-            <a:r>
-              <a:rPr lang="en-US" sz="1200" dirty="0">
-                <a:solidFill>
-                  <a:srgbClr val="1E2B24"/>
-                </a:solidFill>
-                <a:latin typeface="Inter" pitchFamily="34" charset="0"/>
-                <a:ea typeface="Inter" pitchFamily="34" charset="-122"/>
-                <a:cs typeface="Inter" pitchFamily="34" charset="-120"/>
-              </a:rPr>
-              <a:t> dois públicos que precisam um do outro</a:t>
-            </a:r>
-            <a:endParaRPr lang="en-US" sz="1200" dirty="0"/>
-          </a:p>
-        </p:txBody>
-      </p:sp>
-      <p:sp>
-        <p:nvSpPr>
-          <p:cNvPr id="13" name="Text 11"/>
-          <p:cNvSpPr/>
-          <p:nvPr/>
-        </p:nvSpPr>
-        <p:spPr>
-          <a:xfrm>
-            <a:off x="3695700" y="2377430"/>
-            <a:ext cx="3584194" cy="406400"/>
-          </a:xfrm>
-          <a:prstGeom prst="rect">
-            <a:avLst/>
-          </a:prstGeom>
-          <a:noFill/>
-          <a:ln/>
-        </p:spPr>
-        <p:txBody>
-          <a:bodyPr wrap="square" lIns="0" tIns="0" rIns="0" bIns="0" rtlCol="0" anchor="t">
-            <a:normAutofit/>
-          </a:bodyPr>
-          <a:lstStyle/>
-          <a:p>
-            <a:pPr marL="0" indent="0" algn="l">
-              <a:lnSpc>
-                <a:spcPts val="1500"/>
-              </a:lnSpc>
-              <a:buNone/>
-            </a:pPr>
-            <a:r>
-              <a:rPr lang="en-US" sz="1200" b="1" dirty="0">
-                <a:solidFill>
-                  <a:srgbClr val="1E2B24"/>
-                </a:solidFill>
-                <a:latin typeface="Inter" pitchFamily="34" charset="0"/>
-                <a:ea typeface="Inter" pitchFamily="34" charset="-122"/>
-                <a:cs typeface="Inter" pitchFamily="34" charset="-120"/>
-              </a:rPr>
-              <a:t>Vendedores (prioritários):</a:t>
-            </a:r>
-            <a:r>
-              <a:rPr lang="en-US" sz="1200" dirty="0">
-                <a:solidFill>
-                  <a:srgbClr val="1E2B24"/>
-                </a:solidFill>
-                <a:latin typeface="Inter" pitchFamily="34" charset="0"/>
-                <a:ea typeface="Inter" pitchFamily="34" charset="-122"/>
-                <a:cs typeface="Inter" pitchFamily="34" charset="-120"/>
-              </a:rPr>
-              <a:t> hortas, pomares, animais e colmeias</a:t>
-            </a:r>
-            <a:endParaRPr lang="en-US" sz="1200" dirty="0"/>
-          </a:p>
-        </p:txBody>
-      </p:sp>
-      <p:sp>
-        <p:nvSpPr>
-          <p:cNvPr id="14" name="Text 12"/>
-          <p:cNvSpPr/>
-          <p:nvPr/>
-        </p:nvSpPr>
-        <p:spPr>
-          <a:xfrm>
-            <a:off x="3695700" y="2821930"/>
-            <a:ext cx="3584194" cy="406400"/>
-          </a:xfrm>
-          <a:prstGeom prst="rect">
-            <a:avLst/>
-          </a:prstGeom>
-          <a:noFill/>
-          <a:ln/>
-        </p:spPr>
-        <p:txBody>
-          <a:bodyPr wrap="square" lIns="0" tIns="0" rIns="0" bIns="0" rtlCol="0" anchor="t">
-            <a:normAutofit/>
-          </a:bodyPr>
-          <a:lstStyle/>
-          <a:p>
-            <a:pPr marL="0" indent="0" algn="l">
-              <a:lnSpc>
-                <a:spcPts val="1500"/>
-              </a:lnSpc>
-              <a:buNone/>
-            </a:pPr>
-            <a:r>
-              <a:rPr lang="en-US" sz="1200" b="1" dirty="0">
-                <a:solidFill>
-                  <a:srgbClr val="1E2B24"/>
-                </a:solidFill>
-                <a:latin typeface="Inter" pitchFamily="34" charset="0"/>
-                <a:ea typeface="Inter" pitchFamily="34" charset="-122"/>
-                <a:cs typeface="Inter" pitchFamily="34" charset="-120"/>
-              </a:rPr>
-              <a:t>Compradores:</a:t>
-            </a:r>
-            <a:r>
-              <a:rPr lang="en-US" sz="1200" dirty="0">
-                <a:solidFill>
-                  <a:srgbClr val="1E2B24"/>
-                </a:solidFill>
-                <a:latin typeface="Inter" pitchFamily="34" charset="0"/>
-                <a:ea typeface="Inter" pitchFamily="34" charset="-122"/>
-                <a:cs typeface="Inter" pitchFamily="34" charset="-120"/>
-              </a:rPr>
-              <a:t> quem quer frescos a bom preço; restaurantes e cafés</a:t>
-            </a:r>
-            <a:endParaRPr lang="en-US" sz="1200" dirty="0"/>
-          </a:p>
-        </p:txBody>
-      </p:sp>
-      <p:sp>
-        <p:nvSpPr>
-          <p:cNvPr id="15" name="Shape 13"/>
-          <p:cNvSpPr/>
-          <p:nvPr/>
-        </p:nvSpPr>
-        <p:spPr>
-          <a:xfrm>
-            <a:off x="7518400" y="1437630"/>
-            <a:ext cx="3860800" cy="2125960"/>
-          </a:xfrm>
-          <a:prstGeom prst="roundRect">
-            <a:avLst>
-              <a:gd name="adj" fmla="val 3584"/>
-            </a:avLst>
-          </a:prstGeom>
-          <a:solidFill>
-            <a:srgbClr val="FFFDF9"/>
-          </a:solidFill>
-          <a:ln/>
-        </p:spPr>
-        <p:txBody>
-          <a:bodyPr/>
-          <a:lstStyle/>
-          <a:p>
-            <a:endParaRPr lang="pt-PT"/>
-          </a:p>
-        </p:txBody>
-      </p:sp>
-      <p:sp>
-        <p:nvSpPr>
-          <p:cNvPr id="16" name="Shape 14"/>
-          <p:cNvSpPr/>
-          <p:nvPr/>
-        </p:nvSpPr>
-        <p:spPr>
-          <a:xfrm>
-            <a:off x="7518400" y="1437630"/>
-            <a:ext cx="3860800" cy="2125960"/>
-          </a:xfrm>
-          <a:custGeom>
-            <a:avLst/>
-            <a:gdLst/>
-            <a:ahLst/>
-            <a:cxnLst/>
-            <a:rect l="l" t="t" r="r" b="b"/>
-            <a:pathLst>
-              <a:path w="3860800" h="2125960">
-                <a:moveTo>
-                  <a:pt x="0" y="76200"/>
-                </a:moveTo>
-                <a:lnTo>
-                  <a:pt x="0" y="76200"/>
-                </a:lnTo>
-                <a:arcTo wR="76200" hR="76200" stAng="10800000" swAng="5400000"/>
-                <a:lnTo>
-                  <a:pt x="3784600" y="0"/>
-                </a:lnTo>
-                <a:arcTo wR="76200" hR="76200" stAng="16200000" swAng="5400000"/>
-                <a:lnTo>
-                  <a:pt x="3860800" y="76200"/>
-                </a:lnTo>
-                <a:arcTo wR="76200" hR="25400" stAng="0" swAng="-5400000"/>
-                <a:lnTo>
-                  <a:pt x="76200" y="50800"/>
-                </a:lnTo>
-                <a:arcTo wR="76200" hR="25400" stAng="16200000" swAng="-5400000"/>
-                <a:close/>
-              </a:path>
-            </a:pathLst>
-          </a:custGeom>
-          <a:solidFill>
-            <a:srgbClr val="2D6A4F"/>
-          </a:solidFill>
-          <a:ln/>
-        </p:spPr>
-        <p:txBody>
-          <a:bodyPr/>
-          <a:lstStyle/>
-          <a:p>
-            <a:endParaRPr lang="pt-PT"/>
-          </a:p>
-        </p:txBody>
-      </p:sp>
-      <p:sp>
-        <p:nvSpPr>
-          <p:cNvPr id="17" name="Text 15"/>
-          <p:cNvSpPr/>
-          <p:nvPr/>
-        </p:nvSpPr>
-        <p:spPr>
-          <a:xfrm>
-            <a:off x="7708900" y="1640830"/>
-            <a:ext cx="3584194" cy="254000"/>
-          </a:xfrm>
-          <a:prstGeom prst="rect">
-            <a:avLst/>
-          </a:prstGeom>
-          <a:noFill/>
-          <a:ln/>
-        </p:spPr>
-        <p:txBody>
-          <a:bodyPr wrap="square" lIns="0" tIns="0" rIns="0" bIns="0" rtlCol="0" anchor="t">
-            <a:normAutofit/>
-          </a:bodyPr>
-          <a:lstStyle/>
-          <a:p>
-            <a:pPr marL="0" indent="0" algn="l">
-              <a:lnSpc>
-                <a:spcPts val="1800"/>
-              </a:lnSpc>
-              <a:buNone/>
-            </a:pPr>
-            <a:r>
-              <a:rPr lang="en-US" sz="1500" b="1" dirty="0">
-                <a:solidFill>
-                  <a:srgbClr val="2D6A4F"/>
-                </a:solidFill>
-                <a:latin typeface="Inter" pitchFamily="34" charset="0"/>
-                <a:ea typeface="Inter" pitchFamily="34" charset="-122"/>
-                <a:cs typeface="Inter" pitchFamily="34" charset="-120"/>
-              </a:rPr>
-              <a:t>Relações com clientes</a:t>
-            </a:r>
-            <a:endParaRPr lang="en-US" sz="1500" dirty="0"/>
-          </a:p>
-        </p:txBody>
-      </p:sp>
-      <p:sp>
-        <p:nvSpPr>
-          <p:cNvPr id="18" name="Text 16"/>
-          <p:cNvSpPr/>
-          <p:nvPr/>
-        </p:nvSpPr>
-        <p:spPr>
-          <a:xfrm>
-            <a:off x="7708900" y="1932930"/>
-            <a:ext cx="3584194" cy="215900"/>
-          </a:xfrm>
-          <a:prstGeom prst="rect">
-            <a:avLst/>
-          </a:prstGeom>
-          <a:noFill/>
-          <a:ln/>
-        </p:spPr>
-        <p:txBody>
-          <a:bodyPr wrap="square" lIns="0" tIns="0" rIns="0" bIns="0" rtlCol="0" anchor="t">
-            <a:normAutofit/>
-          </a:bodyPr>
-          <a:lstStyle/>
-          <a:p>
-            <a:pPr marL="0" indent="0" algn="l">
-              <a:lnSpc>
-                <a:spcPts val="1500"/>
-              </a:lnSpc>
-              <a:buNone/>
-            </a:pPr>
-            <a:r>
-              <a:rPr lang="en-US" sz="1200" b="1" dirty="0">
-                <a:solidFill>
-                  <a:srgbClr val="1E2B24"/>
-                </a:solidFill>
-                <a:latin typeface="Inter" pitchFamily="34" charset="0"/>
-                <a:ea typeface="Inter" pitchFamily="34" charset="-122"/>
-                <a:cs typeface="Inter" pitchFamily="34" charset="-120"/>
-              </a:rPr>
-              <a:t>Autosserviço</a:t>
-            </a:r>
-            <a:r>
-              <a:rPr lang="en-US" sz="1200" dirty="0">
-                <a:solidFill>
-                  <a:srgbClr val="1E2B24"/>
-                </a:solidFill>
-                <a:latin typeface="Inter" pitchFamily="34" charset="0"/>
-                <a:ea typeface="Inter" pitchFamily="34" charset="-122"/>
-                <a:cs typeface="Inter" pitchFamily="34" charset="-120"/>
-              </a:rPr>
-              <a:t> na app e avaliações mútuas</a:t>
-            </a:r>
-            <a:endParaRPr lang="en-US" sz="1200" dirty="0"/>
-          </a:p>
-        </p:txBody>
-      </p:sp>
-      <p:sp>
-        <p:nvSpPr>
-          <p:cNvPr id="19" name="Text 17"/>
-          <p:cNvSpPr/>
-          <p:nvPr/>
-        </p:nvSpPr>
-        <p:spPr>
-          <a:xfrm>
-            <a:off x="7708900" y="2186930"/>
-            <a:ext cx="3584194" cy="406400"/>
-          </a:xfrm>
-          <a:prstGeom prst="rect">
-            <a:avLst/>
-          </a:prstGeom>
-          <a:noFill/>
-          <a:ln/>
-        </p:spPr>
-        <p:txBody>
-          <a:bodyPr wrap="square" lIns="0" tIns="0" rIns="0" bIns="0" rtlCol="0" anchor="t">
-            <a:normAutofit/>
-          </a:bodyPr>
-          <a:lstStyle/>
-          <a:p>
-            <a:pPr marL="0" indent="0" algn="l">
-              <a:lnSpc>
-                <a:spcPts val="1500"/>
-              </a:lnSpc>
-              <a:buNone/>
-            </a:pPr>
-            <a:r>
-              <a:rPr lang="en-US" sz="1200" b="1" dirty="0">
-                <a:solidFill>
-                  <a:srgbClr val="1E2B24"/>
-                </a:solidFill>
-                <a:latin typeface="Inter" pitchFamily="34" charset="0"/>
-                <a:ea typeface="Inter" pitchFamily="34" charset="-122"/>
-                <a:cs typeface="Inter" pitchFamily="34" charset="-120"/>
-              </a:rPr>
-              <a:t>Arranque:</a:t>
-            </a:r>
-            <a:r>
-              <a:rPr lang="en-US" sz="1200" dirty="0">
-                <a:solidFill>
-                  <a:srgbClr val="1E2B24"/>
-                </a:solidFill>
-                <a:latin typeface="Inter" pitchFamily="34" charset="0"/>
-                <a:ea typeface="Inter" pitchFamily="34" charset="-122"/>
-                <a:cs typeface="Inter" pitchFamily="34" charset="-120"/>
-              </a:rPr>
-              <a:t> ajuda presencial aos primeiros produtores</a:t>
-            </a:r>
-            <a:endParaRPr lang="en-US" sz="1200" dirty="0"/>
-          </a:p>
-        </p:txBody>
-      </p:sp>
-      <p:sp>
-        <p:nvSpPr>
-          <p:cNvPr id="20" name="Text 18"/>
-          <p:cNvSpPr/>
-          <p:nvPr/>
-        </p:nvSpPr>
-        <p:spPr>
-          <a:xfrm>
-            <a:off x="7708900" y="2631430"/>
-            <a:ext cx="3670300" cy="215900"/>
-          </a:xfrm>
-          <a:prstGeom prst="rect">
-            <a:avLst/>
-          </a:prstGeom>
-          <a:noFill/>
-          <a:ln/>
-        </p:spPr>
-        <p:txBody>
-          <a:bodyPr wrap="square" lIns="0" tIns="0" rIns="0" bIns="0" rtlCol="0" anchor="t">
-            <a:normAutofit/>
-          </a:bodyPr>
-          <a:lstStyle/>
-          <a:p>
-            <a:pPr marL="0" indent="0" algn="l">
-              <a:lnSpc>
-                <a:spcPts val="1500"/>
-              </a:lnSpc>
-              <a:buNone/>
-            </a:pPr>
-            <a:r>
-              <a:rPr lang="en-US" sz="1200" b="1" dirty="0">
-                <a:solidFill>
-                  <a:srgbClr val="1E2B24"/>
-                </a:solidFill>
-                <a:latin typeface="Inter" pitchFamily="34" charset="0"/>
-                <a:ea typeface="Inter" pitchFamily="34" charset="-122"/>
-                <a:cs typeface="Inter" pitchFamily="34" charset="-120"/>
-              </a:rPr>
-              <a:t>“Convida um vizinho”</a:t>
-            </a:r>
-            <a:r>
-              <a:rPr lang="en-US" sz="1200" dirty="0">
-                <a:solidFill>
-                  <a:srgbClr val="1E2B24"/>
-                </a:solidFill>
-                <a:latin typeface="Inter" pitchFamily="34" charset="0"/>
-                <a:ea typeface="Inter" pitchFamily="34" charset="-122"/>
-                <a:cs typeface="Inter" pitchFamily="34" charset="-120"/>
-              </a:rPr>
-              <a:t> com crédito para ambos</a:t>
-            </a:r>
-            <a:endParaRPr lang="en-US" sz="1200" dirty="0"/>
-          </a:p>
-        </p:txBody>
-      </p:sp>
-      <p:sp>
-        <p:nvSpPr>
-          <p:cNvPr id="21" name="Text 19"/>
-          <p:cNvSpPr/>
-          <p:nvPr/>
-        </p:nvSpPr>
-        <p:spPr>
-          <a:xfrm>
-            <a:off x="7708900" y="2885430"/>
-            <a:ext cx="3584194" cy="215900"/>
-          </a:xfrm>
-          <a:prstGeom prst="rect">
-            <a:avLst/>
-          </a:prstGeom>
-          <a:noFill/>
-          <a:ln/>
-        </p:spPr>
-        <p:txBody>
-          <a:bodyPr wrap="square" lIns="0" tIns="0" rIns="0" bIns="0" rtlCol="0" anchor="t">
-            <a:normAutofit/>
-          </a:bodyPr>
-          <a:lstStyle/>
-          <a:p>
-            <a:pPr marL="0" indent="0" algn="l">
-              <a:lnSpc>
-                <a:spcPts val="1500"/>
-              </a:lnSpc>
-              <a:buNone/>
-            </a:pPr>
-            <a:r>
-              <a:rPr lang="en-US" sz="1200" b="1" dirty="0">
-                <a:solidFill>
-                  <a:srgbClr val="1E2B24"/>
-                </a:solidFill>
-                <a:latin typeface="Inter" pitchFamily="34" charset="0"/>
-                <a:ea typeface="Inter" pitchFamily="34" charset="-122"/>
-                <a:cs typeface="Inter" pitchFamily="34" charset="-120"/>
-              </a:rPr>
-              <a:t>Fidelização:</a:t>
-            </a:r>
-            <a:r>
-              <a:rPr lang="en-US" sz="1200" dirty="0">
-                <a:solidFill>
-                  <a:srgbClr val="1E2B24"/>
-                </a:solidFill>
-                <a:latin typeface="Inter" pitchFamily="34" charset="0"/>
-                <a:ea typeface="Inter" pitchFamily="34" charset="-122"/>
-                <a:cs typeface="Inter" pitchFamily="34" charset="-120"/>
-              </a:rPr>
-              <a:t> alertas de disponibilidade</a:t>
-            </a:r>
-            <a:endParaRPr lang="en-US" sz="1200" dirty="0"/>
-          </a:p>
-        </p:txBody>
-      </p:sp>
-      <p:sp>
-        <p:nvSpPr>
-          <p:cNvPr id="22" name="Shape 20"/>
-          <p:cNvSpPr/>
-          <p:nvPr/>
-        </p:nvSpPr>
-        <p:spPr>
-          <a:xfrm>
-            <a:off x="3505200" y="3715990"/>
-            <a:ext cx="3860800" cy="2126010"/>
-          </a:xfrm>
-          <a:prstGeom prst="roundRect">
-            <a:avLst>
-              <a:gd name="adj" fmla="val 3584"/>
-            </a:avLst>
-          </a:prstGeom>
-          <a:solidFill>
-            <a:srgbClr val="FFFDF9"/>
-          </a:solidFill>
-          <a:ln/>
-        </p:spPr>
-        <p:txBody>
-          <a:bodyPr/>
-          <a:lstStyle/>
-          <a:p>
-            <a:endParaRPr lang="pt-PT"/>
-          </a:p>
-        </p:txBody>
-      </p:sp>
-      <p:sp>
-        <p:nvSpPr>
-          <p:cNvPr id="23" name="Shape 21"/>
-          <p:cNvSpPr/>
-          <p:nvPr/>
-        </p:nvSpPr>
-        <p:spPr>
-          <a:xfrm>
-            <a:off x="3505200" y="3715990"/>
-            <a:ext cx="3860800" cy="2126010"/>
-          </a:xfrm>
-          <a:custGeom>
-            <a:avLst/>
-            <a:gdLst/>
-            <a:ahLst/>
-            <a:cxnLst/>
-            <a:rect l="l" t="t" r="r" b="b"/>
-            <a:pathLst>
-              <a:path w="3860800" h="2126010">
-                <a:moveTo>
-                  <a:pt x="0" y="76200"/>
-                </a:moveTo>
-                <a:lnTo>
-                  <a:pt x="0" y="76200"/>
-                </a:lnTo>
-                <a:arcTo wR="76200" hR="76200" stAng="10800000" swAng="5400000"/>
-                <a:lnTo>
-                  <a:pt x="3784600" y="0"/>
-                </a:lnTo>
-                <a:arcTo wR="76200" hR="76200" stAng="16200000" swAng="5400000"/>
-                <a:lnTo>
-                  <a:pt x="3860800" y="76200"/>
-                </a:lnTo>
-                <a:arcTo wR="76200" hR="25400" stAng="0" swAng="-5400000"/>
-                <a:lnTo>
-                  <a:pt x="76200" y="50800"/>
-                </a:lnTo>
-                <a:arcTo wR="76200" hR="25400" stAng="16200000" swAng="-5400000"/>
-                <a:close/>
-              </a:path>
-            </a:pathLst>
-          </a:custGeom>
-          <a:solidFill>
-            <a:srgbClr val="2D6A4F"/>
-          </a:solidFill>
-          <a:ln/>
-        </p:spPr>
-        <p:txBody>
-          <a:bodyPr/>
-          <a:lstStyle/>
-          <a:p>
-            <a:endParaRPr lang="pt-PT"/>
-          </a:p>
-        </p:txBody>
-      </p:sp>
-      <p:sp>
-        <p:nvSpPr>
-          <p:cNvPr id="24" name="Text 22"/>
-          <p:cNvSpPr/>
-          <p:nvPr/>
-        </p:nvSpPr>
-        <p:spPr>
-          <a:xfrm>
-            <a:off x="3695700" y="3919190"/>
-            <a:ext cx="3584194" cy="254000"/>
-          </a:xfrm>
-          <a:prstGeom prst="rect">
-            <a:avLst/>
-          </a:prstGeom>
-          <a:noFill/>
-          <a:ln/>
-        </p:spPr>
-        <p:txBody>
-          <a:bodyPr wrap="square" lIns="0" tIns="0" rIns="0" bIns="0" rtlCol="0" anchor="t">
-            <a:normAutofit/>
-          </a:bodyPr>
-          <a:lstStyle/>
-          <a:p>
-            <a:pPr marL="0" indent="0" algn="l">
-              <a:lnSpc>
-                <a:spcPts val="1800"/>
-              </a:lnSpc>
-              <a:buNone/>
-            </a:pPr>
-            <a:r>
-              <a:rPr lang="en-US" sz="1500" b="1" dirty="0">
-                <a:solidFill>
-                  <a:srgbClr val="2D6A4F"/>
-                </a:solidFill>
-                <a:latin typeface="Inter" pitchFamily="34" charset="0"/>
-                <a:ea typeface="Inter" pitchFamily="34" charset="-122"/>
-                <a:cs typeface="Inter" pitchFamily="34" charset="-120"/>
-              </a:rPr>
-              <a:t>Canais</a:t>
-            </a:r>
-            <a:endParaRPr lang="en-US" sz="1500" dirty="0"/>
-          </a:p>
-        </p:txBody>
-      </p:sp>
-      <p:sp>
-        <p:nvSpPr>
-          <p:cNvPr id="25" name="Text 23"/>
-          <p:cNvSpPr/>
-          <p:nvPr/>
-        </p:nvSpPr>
-        <p:spPr>
-          <a:xfrm>
-            <a:off x="3695700" y="4211290"/>
-            <a:ext cx="3584194" cy="215900"/>
-          </a:xfrm>
-          <a:prstGeom prst="rect">
-            <a:avLst/>
-          </a:prstGeom>
-          <a:noFill/>
-          <a:ln/>
-        </p:spPr>
-        <p:txBody>
-          <a:bodyPr wrap="square" lIns="0" tIns="0" rIns="0" bIns="0" rtlCol="0" anchor="t">
-            <a:normAutofit/>
-          </a:bodyPr>
-          <a:lstStyle/>
-          <a:p>
-            <a:pPr marL="0" indent="0" algn="l">
-              <a:lnSpc>
-                <a:spcPts val="1500"/>
-              </a:lnSpc>
-              <a:buNone/>
-            </a:pPr>
-            <a:r>
-              <a:rPr lang="en-US" sz="1200" b="1" dirty="0">
-                <a:solidFill>
-                  <a:srgbClr val="1E2B24"/>
-                </a:solidFill>
-                <a:latin typeface="Inter" pitchFamily="34" charset="0"/>
-                <a:ea typeface="Inter" pitchFamily="34" charset="-122"/>
-                <a:cs typeface="Inter" pitchFamily="34" charset="-120"/>
-              </a:rPr>
-              <a:t>Conhecer:</a:t>
-            </a:r>
-            <a:r>
-              <a:rPr lang="en-US" sz="1200" dirty="0">
-                <a:solidFill>
-                  <a:srgbClr val="1E2B24"/>
-                </a:solidFill>
-                <a:latin typeface="Inter" pitchFamily="34" charset="0"/>
-                <a:ea typeface="Inter" pitchFamily="34" charset="-122"/>
-                <a:cs typeface="Inter" pitchFamily="34" charset="-120"/>
-              </a:rPr>
-              <a:t> juntas, feiras e redes sociais</a:t>
-            </a:r>
-            <a:endParaRPr lang="en-US" sz="1200" dirty="0"/>
-          </a:p>
-        </p:txBody>
-      </p:sp>
-      <p:sp>
-        <p:nvSpPr>
-          <p:cNvPr id="26" name="Text 24"/>
-          <p:cNvSpPr/>
-          <p:nvPr/>
-        </p:nvSpPr>
-        <p:spPr>
-          <a:xfrm>
-            <a:off x="3695700" y="4465290"/>
-            <a:ext cx="3584194" cy="215900"/>
-          </a:xfrm>
-          <a:prstGeom prst="rect">
-            <a:avLst/>
-          </a:prstGeom>
-          <a:noFill/>
-          <a:ln/>
-        </p:spPr>
-        <p:txBody>
-          <a:bodyPr wrap="square" lIns="0" tIns="0" rIns="0" bIns="0" rtlCol="0" anchor="t">
-            <a:normAutofit/>
-          </a:bodyPr>
-          <a:lstStyle/>
-          <a:p>
-            <a:pPr marL="0" indent="0" algn="l">
-              <a:lnSpc>
-                <a:spcPts val="1500"/>
-              </a:lnSpc>
-              <a:buNone/>
-            </a:pPr>
-            <a:r>
-              <a:rPr lang="en-US" sz="1200" b="1" dirty="0">
-                <a:solidFill>
-                  <a:srgbClr val="1E2B24"/>
-                </a:solidFill>
-                <a:latin typeface="Inter" pitchFamily="34" charset="0"/>
-                <a:ea typeface="Inter" pitchFamily="34" charset="-122"/>
-                <a:cs typeface="Inter" pitchFamily="34" charset="-120"/>
-              </a:rPr>
-              <a:t>Comprar:</a:t>
-            </a:r>
-            <a:r>
-              <a:rPr lang="en-US" sz="1200" dirty="0">
-                <a:solidFill>
-                  <a:srgbClr val="1E2B24"/>
-                </a:solidFill>
-                <a:latin typeface="Inter" pitchFamily="34" charset="0"/>
-                <a:ea typeface="Inter" pitchFamily="34" charset="-122"/>
-                <a:cs typeface="Inter" pitchFamily="34" charset="-120"/>
-              </a:rPr>
-              <a:t> app com mapa e reserva</a:t>
-            </a:r>
-            <a:endParaRPr lang="en-US" sz="1200" dirty="0"/>
-          </a:p>
-        </p:txBody>
-      </p:sp>
-      <p:sp>
-        <p:nvSpPr>
-          <p:cNvPr id="27" name="Text 25"/>
-          <p:cNvSpPr/>
-          <p:nvPr/>
-        </p:nvSpPr>
-        <p:spPr>
-          <a:xfrm>
-            <a:off x="3695700" y="4719290"/>
-            <a:ext cx="3584194" cy="406400"/>
-          </a:xfrm>
-          <a:prstGeom prst="rect">
-            <a:avLst/>
-          </a:prstGeom>
-          <a:noFill/>
-          <a:ln/>
-        </p:spPr>
-        <p:txBody>
-          <a:bodyPr wrap="square" lIns="0" tIns="0" rIns="0" bIns="0" rtlCol="0" anchor="t">
-            <a:normAutofit/>
-          </a:bodyPr>
-          <a:lstStyle/>
-          <a:p>
-            <a:pPr marL="0" indent="0" algn="l">
-              <a:lnSpc>
-                <a:spcPts val="1500"/>
-              </a:lnSpc>
-              <a:buNone/>
-            </a:pPr>
-            <a:r>
-              <a:rPr lang="en-US" sz="1200" b="1" dirty="0">
-                <a:solidFill>
-                  <a:srgbClr val="1E2B24"/>
-                </a:solidFill>
-                <a:latin typeface="Inter" pitchFamily="34" charset="0"/>
-                <a:ea typeface="Inter" pitchFamily="34" charset="-122"/>
-                <a:cs typeface="Inter" pitchFamily="34" charset="-120"/>
-              </a:rPr>
-              <a:t>Receber:</a:t>
-            </a:r>
-            <a:r>
-              <a:rPr lang="en-US" sz="1200" dirty="0">
-                <a:solidFill>
-                  <a:srgbClr val="1E2B24"/>
-                </a:solidFill>
-                <a:latin typeface="Inter" pitchFamily="34" charset="0"/>
-                <a:ea typeface="Inter" pitchFamily="34" charset="-122"/>
-                <a:cs typeface="Inter" pitchFamily="34" charset="-120"/>
-              </a:rPr>
-              <a:t> recolha no produtor ou em ponto partilhado</a:t>
-            </a:r>
-            <a:endParaRPr lang="en-US" sz="1200" dirty="0"/>
-          </a:p>
-        </p:txBody>
-      </p:sp>
-      <p:sp>
-        <p:nvSpPr>
-          <p:cNvPr id="28" name="Text 26"/>
-          <p:cNvSpPr/>
-          <p:nvPr/>
-        </p:nvSpPr>
-        <p:spPr>
-          <a:xfrm>
-            <a:off x="3695700" y="5163790"/>
-            <a:ext cx="3584194" cy="215900"/>
-          </a:xfrm>
-          <a:prstGeom prst="rect">
-            <a:avLst/>
-          </a:prstGeom>
-          <a:noFill/>
-          <a:ln/>
-        </p:spPr>
-        <p:txBody>
-          <a:bodyPr wrap="square" lIns="0" tIns="0" rIns="0" bIns="0" rtlCol="0" anchor="t">
-            <a:normAutofit/>
-          </a:bodyPr>
-          <a:lstStyle/>
-          <a:p>
-            <a:pPr marL="0" indent="0" algn="l">
-              <a:lnSpc>
-                <a:spcPts val="1500"/>
-              </a:lnSpc>
-              <a:buNone/>
-            </a:pPr>
-            <a:r>
-              <a:rPr lang="en-US" sz="1200" b="1" dirty="0">
-                <a:solidFill>
-                  <a:srgbClr val="1E2B24"/>
-                </a:solidFill>
-                <a:latin typeface="Inter" pitchFamily="34" charset="0"/>
-                <a:ea typeface="Inter" pitchFamily="34" charset="-122"/>
-                <a:cs typeface="Inter" pitchFamily="34" charset="-120"/>
-              </a:rPr>
-              <a:t>Voltar:</a:t>
-            </a:r>
-            <a:r>
-              <a:rPr lang="en-US" sz="1200" dirty="0">
-                <a:solidFill>
-                  <a:srgbClr val="1E2B24"/>
-                </a:solidFill>
-                <a:latin typeface="Inter" pitchFamily="34" charset="0"/>
-                <a:ea typeface="Inter" pitchFamily="34" charset="-122"/>
-                <a:cs typeface="Inter" pitchFamily="34" charset="-120"/>
-              </a:rPr>
-              <a:t> favoritos e alertas “avisar-me”</a:t>
-            </a:r>
-            <a:endParaRPr lang="en-US" sz="1200" dirty="0"/>
-          </a:p>
-        </p:txBody>
-      </p:sp>
-      <p:sp>
-        <p:nvSpPr>
-          <p:cNvPr id="29" name="Shape 27"/>
-          <p:cNvSpPr/>
-          <p:nvPr/>
-        </p:nvSpPr>
-        <p:spPr>
-          <a:xfrm>
-            <a:off x="7518400" y="3715990"/>
-            <a:ext cx="3860800" cy="2126010"/>
-          </a:xfrm>
-          <a:prstGeom prst="roundRect">
-            <a:avLst>
-              <a:gd name="adj" fmla="val 3584"/>
-            </a:avLst>
-          </a:prstGeom>
-          <a:solidFill>
-            <a:srgbClr val="F5E3D6"/>
-          </a:solidFill>
-          <a:ln/>
-        </p:spPr>
-        <p:txBody>
-          <a:bodyPr/>
-          <a:lstStyle/>
-          <a:p>
-            <a:endParaRPr lang="pt-PT"/>
-          </a:p>
-        </p:txBody>
-      </p:sp>
-      <p:sp>
-        <p:nvSpPr>
-          <p:cNvPr id="30" name="Shape 28"/>
-          <p:cNvSpPr/>
-          <p:nvPr/>
-        </p:nvSpPr>
-        <p:spPr>
-          <a:xfrm>
-            <a:off x="7518400" y="3715990"/>
-            <a:ext cx="3860800" cy="2126010"/>
-          </a:xfrm>
-          <a:custGeom>
-            <a:avLst/>
-            <a:gdLst/>
-            <a:ahLst/>
-            <a:cxnLst/>
-            <a:rect l="l" t="t" r="r" b="b"/>
-            <a:pathLst>
-              <a:path w="3860800" h="2126010">
-                <a:moveTo>
-                  <a:pt x="0" y="76200"/>
-                </a:moveTo>
-                <a:lnTo>
-                  <a:pt x="0" y="76200"/>
-                </a:lnTo>
-                <a:arcTo wR="76200" hR="76200" stAng="10800000" swAng="5400000"/>
-                <a:lnTo>
-                  <a:pt x="3784600" y="0"/>
-                </a:lnTo>
-                <a:arcTo wR="76200" hR="76200" stAng="16200000" swAng="5400000"/>
-                <a:lnTo>
-                  <a:pt x="3860800" y="76200"/>
-                </a:lnTo>
-                <a:arcTo wR="76200" hR="25400" stAng="0" swAng="-5400000"/>
-                <a:lnTo>
-                  <a:pt x="76200" y="50800"/>
-                </a:lnTo>
-                <a:arcTo wR="76200" hR="25400" stAng="16200000" swAng="-5400000"/>
-                <a:close/>
-              </a:path>
-            </a:pathLst>
-          </a:custGeom>
-          <a:solidFill>
-            <a:srgbClr val="C5703C"/>
-          </a:solidFill>
-          <a:ln/>
-        </p:spPr>
-        <p:txBody>
-          <a:bodyPr/>
-          <a:lstStyle/>
-          <a:p>
-            <a:endParaRPr lang="pt-PT"/>
-          </a:p>
-        </p:txBody>
-      </p:sp>
-      <p:sp>
-        <p:nvSpPr>
-          <p:cNvPr id="31" name="Text 29"/>
-          <p:cNvSpPr/>
-          <p:nvPr/>
-        </p:nvSpPr>
-        <p:spPr>
-          <a:xfrm>
-            <a:off x="7708900" y="3919190"/>
-            <a:ext cx="3584194" cy="254000"/>
-          </a:xfrm>
-          <a:prstGeom prst="rect">
-            <a:avLst/>
-          </a:prstGeom>
-          <a:noFill/>
-          <a:ln/>
-        </p:spPr>
-        <p:txBody>
-          <a:bodyPr wrap="square" lIns="0" tIns="0" rIns="0" bIns="0" rtlCol="0" anchor="t">
-            <a:normAutofit/>
-          </a:bodyPr>
-          <a:lstStyle/>
-          <a:p>
-            <a:pPr marL="0" indent="0" algn="l">
-              <a:lnSpc>
-                <a:spcPts val="1800"/>
-              </a:lnSpc>
-              <a:buNone/>
-            </a:pPr>
-            <a:r>
-              <a:rPr lang="en-US" sz="1500" b="1" dirty="0">
-                <a:solidFill>
-                  <a:srgbClr val="A85A2A"/>
-                </a:solidFill>
-                <a:latin typeface="Inter" pitchFamily="34" charset="0"/>
-                <a:ea typeface="Inter" pitchFamily="34" charset="-122"/>
-                <a:cs typeface="Inter" pitchFamily="34" charset="-120"/>
-              </a:rPr>
-              <a:t>Fontes de receita</a:t>
-            </a:r>
-            <a:endParaRPr lang="en-US" sz="1500" dirty="0"/>
-          </a:p>
-        </p:txBody>
-      </p:sp>
-      <p:sp>
-        <p:nvSpPr>
-          <p:cNvPr id="32" name="Text 30"/>
-          <p:cNvSpPr/>
-          <p:nvPr/>
-        </p:nvSpPr>
-        <p:spPr>
-          <a:xfrm>
-            <a:off x="7708900" y="4223990"/>
-            <a:ext cx="3584194" cy="360660"/>
-          </a:xfrm>
-          <a:prstGeom prst="rect">
-            <a:avLst/>
-          </a:prstGeom>
-          <a:noFill/>
-          <a:ln/>
-        </p:spPr>
-        <p:txBody>
-          <a:bodyPr wrap="square" lIns="0" tIns="0" rIns="0" bIns="0" rtlCol="0" anchor="t">
-            <a:normAutofit/>
-          </a:bodyPr>
-          <a:lstStyle/>
-          <a:p>
-            <a:pPr marL="0" indent="0" algn="l">
-              <a:lnSpc>
-                <a:spcPts val="2640"/>
-              </a:lnSpc>
-              <a:buNone/>
-            </a:pPr>
-            <a:r>
-              <a:rPr lang="en-US" sz="2400" b="1" dirty="0">
-                <a:solidFill>
-                  <a:srgbClr val="1E2B24"/>
-                </a:solidFill>
-                <a:latin typeface="Inter" pitchFamily="34" charset="0"/>
-                <a:ea typeface="Inter" pitchFamily="34" charset="-122"/>
-                <a:cs typeface="Inter" pitchFamily="34" charset="-120"/>
-              </a:rPr>
-              <a:t>0,50 € + 5 %</a:t>
-            </a:r>
-            <a:endParaRPr lang="en-US" sz="2400" dirty="0"/>
-          </a:p>
-        </p:txBody>
-      </p:sp>
-      <p:sp>
-        <p:nvSpPr>
-          <p:cNvPr id="33" name="Text 31"/>
-          <p:cNvSpPr/>
-          <p:nvPr/>
-        </p:nvSpPr>
-        <p:spPr>
-          <a:xfrm>
-            <a:off x="7708900" y="4635450"/>
-            <a:ext cx="3584194" cy="406400"/>
-          </a:xfrm>
-          <a:prstGeom prst="rect">
-            <a:avLst/>
-          </a:prstGeom>
-          <a:noFill/>
-          <a:ln/>
-        </p:spPr>
-        <p:txBody>
-          <a:bodyPr wrap="square" lIns="0" tIns="0" rIns="0" bIns="0" rtlCol="0" anchor="t">
-            <a:normAutofit/>
-          </a:bodyPr>
-          <a:lstStyle/>
-          <a:p>
-            <a:pPr marL="0" indent="0" algn="l">
-              <a:lnSpc>
-                <a:spcPts val="1500"/>
-              </a:lnSpc>
-              <a:buNone/>
-            </a:pPr>
-            <a:r>
-              <a:rPr lang="en-US" sz="1200" dirty="0">
-                <a:solidFill>
-                  <a:srgbClr val="1E2B24"/>
-                </a:solidFill>
-                <a:latin typeface="Inter" pitchFamily="34" charset="0"/>
-                <a:ea typeface="Inter" pitchFamily="34" charset="-122"/>
-                <a:cs typeface="Inter" pitchFamily="34" charset="-120"/>
-              </a:rPr>
-              <a:t>por compra, pago pelo comprador; </a:t>
-            </a:r>
-            <a:r>
-              <a:rPr lang="en-US" sz="1200" b="1" dirty="0">
-                <a:solidFill>
-                  <a:srgbClr val="1E2B24"/>
-                </a:solidFill>
-                <a:latin typeface="Inter" pitchFamily="34" charset="0"/>
-                <a:ea typeface="Inter" pitchFamily="34" charset="-122"/>
-                <a:cs typeface="Inter" pitchFamily="34" charset="-120"/>
-              </a:rPr>
-              <a:t>vender é grátis</a:t>
-            </a:r>
-            <a:endParaRPr lang="en-US" sz="1200" dirty="0"/>
-          </a:p>
-        </p:txBody>
-      </p:sp>
-      <p:sp>
-        <p:nvSpPr>
-          <p:cNvPr id="34" name="Text 32"/>
-          <p:cNvSpPr/>
-          <p:nvPr/>
-        </p:nvSpPr>
-        <p:spPr>
-          <a:xfrm>
-            <a:off x="7708900" y="5092650"/>
-            <a:ext cx="3584194" cy="406400"/>
-          </a:xfrm>
-          <a:prstGeom prst="rect">
-            <a:avLst/>
-          </a:prstGeom>
-          <a:noFill/>
-          <a:ln/>
-        </p:spPr>
-        <p:txBody>
-          <a:bodyPr wrap="square" lIns="0" tIns="0" rIns="0" bIns="0" rtlCol="0" anchor="t">
-            <a:normAutofit/>
-          </a:bodyPr>
-          <a:lstStyle/>
-          <a:p>
-            <a:pPr marL="0" indent="0" algn="l">
-              <a:lnSpc>
-                <a:spcPts val="1500"/>
-              </a:lnSpc>
-              <a:buNone/>
-            </a:pPr>
-            <a:r>
-              <a:rPr lang="en-US" sz="1200" b="1" dirty="0">
-                <a:solidFill>
-                  <a:srgbClr val="1E2B24"/>
-                </a:solidFill>
-                <a:latin typeface="Inter" pitchFamily="34" charset="0"/>
-                <a:ea typeface="Inter" pitchFamily="34" charset="-122"/>
-                <a:cs typeface="Inter" pitchFamily="34" charset="-120"/>
-              </a:rPr>
-              <a:t>Extra:</a:t>
-            </a:r>
-            <a:r>
-              <a:rPr lang="en-US" sz="1200" dirty="0">
-                <a:solidFill>
-                  <a:srgbClr val="1E2B24"/>
-                </a:solidFill>
-                <a:latin typeface="Inter" pitchFamily="34" charset="0"/>
-                <a:ea typeface="Inter" pitchFamily="34" charset="-122"/>
-                <a:cs typeface="Inter" pitchFamily="34" charset="-120"/>
-              </a:rPr>
-              <a:t> destaque no mapa · </a:t>
-            </a:r>
-            <a:r>
-              <a:rPr lang="en-US" sz="1200" b="1" dirty="0">
-                <a:solidFill>
-                  <a:srgbClr val="1E2B24"/>
-                </a:solidFill>
-                <a:latin typeface="Inter" pitchFamily="34" charset="0"/>
-                <a:ea typeface="Inter" pitchFamily="34" charset="-122"/>
-                <a:cs typeface="Inter" pitchFamily="34" charset="-120"/>
-              </a:rPr>
-              <a:t>Fase 2:</a:t>
-            </a:r>
-            <a:r>
-              <a:rPr lang="en-US" sz="1200" dirty="0">
-                <a:solidFill>
-                  <a:srgbClr val="1E2B24"/>
-                </a:solidFill>
-                <a:latin typeface="Inter" pitchFamily="34" charset="0"/>
-                <a:ea typeface="Inter" pitchFamily="34" charset="-122"/>
-                <a:cs typeface="Inter" pitchFamily="34" charset="-120"/>
-              </a:rPr>
-              <a:t> GrowNear Pro</a:t>
-            </a:r>
-            <a:endParaRPr lang="en-US" sz="1200" dirty="0"/>
-          </a:p>
-        </p:txBody>
-      </p:sp>
-      <p:sp>
-        <p:nvSpPr>
-          <p:cNvPr id="35" name="Text 33"/>
-          <p:cNvSpPr/>
-          <p:nvPr/>
-        </p:nvSpPr>
-        <p:spPr>
-          <a:xfrm>
-            <a:off x="812800" y="6238280"/>
-            <a:ext cx="914281" cy="238720"/>
-          </a:xfrm>
-          <a:prstGeom prst="rect">
-            <a:avLst/>
-          </a:prstGeom>
-          <a:noFill/>
-          <a:ln/>
-        </p:spPr>
-        <p:txBody>
-          <a:bodyPr wrap="square" lIns="0" tIns="0" rIns="0" bIns="0" rtlCol="0" anchor="t">
-            <a:normAutofit/>
-          </a:bodyPr>
-          <a:lstStyle/>
-          <a:p>
-            <a:pPr marL="0" indent="0" algn="l">
-              <a:lnSpc>
-                <a:spcPts val="1680"/>
-              </a:lnSpc>
-              <a:buNone/>
-            </a:pPr>
-            <a:r>
-              <a:rPr lang="en-US" sz="1200" b="1" dirty="0">
-                <a:solidFill>
-                  <a:srgbClr val="2D6A4F"/>
-                </a:solidFill>
-                <a:latin typeface="Inter" pitchFamily="34" charset="0"/>
-                <a:ea typeface="Inter" pitchFamily="34" charset="-122"/>
-                <a:cs typeface="Inter" pitchFamily="34" charset="-120"/>
-              </a:rPr>
-              <a:t>GrowNear</a:t>
-            </a:r>
-            <a:endParaRPr lang="en-US" sz="1200" dirty="0"/>
-          </a:p>
-        </p:txBody>
-      </p:sp>
-      <p:sp>
-        <p:nvSpPr>
-          <p:cNvPr id="36" name="Text 34"/>
           <p:cNvSpPr/>
           <p:nvPr/>
         </p:nvSpPr>

</xml_diff>